<commit_message>
Release PostEx 0.4.0a1 Trusted Export
</commit_message>
<xml_diff>
--- a/assets/templates/bioinformatics-pipeline/36x48-landscape/template.pptx
+++ b/assets/templates/bioinformatics-pipeline/36x48-landscape/template.pptx
@@ -2,13 +2,13 @@
 <file path=ppt/presentation.xml><?xml version="1.0" encoding="utf-8"?>
 <p:presentation xmlns:p="http://schemas.openxmlformats.org/presentationml/2006/main">
   <p:sldMasterIdLst>
-    <p:sldMasterId xmlns:r="http://schemas.openxmlformats.org/officeDocument/2006/relationships" id="2147483648" r:id="R029c03b2340b4018"/>
+    <p:sldMasterId xmlns:r="http://schemas.openxmlformats.org/officeDocument/2006/relationships" id="2147483648" r:id="Rd8c357471a3c406a"/>
   </p:sldMasterIdLst>
   <p:notesMasterIdLst>
-    <p:notesMasterId xmlns:r="http://schemas.openxmlformats.org/officeDocument/2006/relationships" r:id="R04f9e63887e44ff0"/>
+    <p:notesMasterId xmlns:r="http://schemas.openxmlformats.org/officeDocument/2006/relationships" r:id="R1953748fe7074824"/>
   </p:notesMasterIdLst>
   <p:sldIdLst>
-    <p:sldId xmlns:r="http://schemas.openxmlformats.org/officeDocument/2006/relationships" id="256" r:id="R6ee3820b644840b2"/>
+    <p:sldId xmlns:r="http://schemas.openxmlformats.org/officeDocument/2006/relationships" id="256" r:id="Rf8987b7a61a34849"/>
   </p:sldIdLst>
   <p:sldSz cx="43891200" cy="32918400"/>
   <p:notesSz cx="6858000" cy="9144000"/>
@@ -525,7 +525,7 @@
   </p:cSld>
   <p:clrMap bg1="lt1" tx1="dk1" bg2="lt2" tx2="dk2" accent1="accent1" accent2="accent2" accent3="accent3" accent4="accent4" accent5="accent5" accent6="accent6" hlink="hlink" folHlink="folHlink"/>
   <p:sldLayoutIdLst>
-    <p:sldLayoutId xmlns:r="http://schemas.openxmlformats.org/officeDocument/2006/relationships" id="2147483649" r:id="R1da0784496c642fb"/>
+    <p:sldLayoutId xmlns:r="http://schemas.openxmlformats.org/officeDocument/2006/relationships" id="2147483649" r:id="Rd23c79ea39f640fb"/>
   </p:sldLayoutIdLst>
   <p:txStyles>
     <p:titleStyle>
@@ -1073,10 +1073,10 @@
       </p:grpSpPr>
       <p:sp>
         <p:nvSpPr>
-          <p:cNvPr id="92" name="header-band">
-            <a:extLst xmlns:a="http://schemas.openxmlformats.org/drawingml/2006/main">
-              <a:ext uri="{FF2B5EF4-FFF2-40B4-BE49-F238E27FC236}">
-                <a16:creationId xmlns:a16="http://schemas.microsoft.com/office/drawing/2014/main" id="{4E8EF257-6732-4187-8728-D4D901F8E024}"/>
+          <p:cNvPr id="93" name="header-band">
+            <a:extLst xmlns:a="http://schemas.openxmlformats.org/drawingml/2006/main">
+              <a:ext uri="{FF2B5EF4-FFF2-40B4-BE49-F238E27FC236}">
+                <a16:creationId xmlns:a16="http://schemas.microsoft.com/office/drawing/2014/main" id="{E162C301-47B0-4A94-9305-2DCDCE68B4A2}"/>
               </a:ext>
             </a:extLst>
           </p:cNvPr>
@@ -1109,7 +1109,7 @@
           <p:cNvPr id="2" name="top-accent">
             <a:extLst xmlns:a="http://schemas.openxmlformats.org/drawingml/2006/main">
               <a:ext uri="{FF2B5EF4-FFF2-40B4-BE49-F238E27FC236}">
-                <a16:creationId xmlns:a16="http://schemas.microsoft.com/office/drawing/2014/main" id="{1D1852F0-0667-473F-9FEA-54F421198D52}"/>
+                <a16:creationId xmlns:a16="http://schemas.microsoft.com/office/drawing/2014/main" id="{C546FEA7-6964-4B86-9EB3-E441D4566E94}"/>
               </a:ext>
             </a:extLst>
           </p:cNvPr>
@@ -1142,7 +1142,7 @@
           <p:cNvPr id="3" name="poster-title">
             <a:extLst xmlns:a="http://schemas.openxmlformats.org/drawingml/2006/main">
               <a:ext uri="{FF2B5EF4-FFF2-40B4-BE49-F238E27FC236}">
-                <a16:creationId xmlns:a16="http://schemas.microsoft.com/office/drawing/2014/main" id="{85BFA75A-B968-4AC0-AEC3-EB8F7D9C6C10}"/>
+                <a16:creationId xmlns:a16="http://schemas.microsoft.com/office/drawing/2014/main" id="{0DE6A43A-6B57-4CC8-9016-468F656B6F63}"/>
               </a:ext>
             </a:extLst>
           </p:cNvPr>
@@ -1192,7 +1192,7 @@
           <p:cNvPr id="4" name="authors">
             <a:extLst xmlns:a="http://schemas.openxmlformats.org/drawingml/2006/main">
               <a:ext uri="{FF2B5EF4-FFF2-40B4-BE49-F238E27FC236}">
-                <a16:creationId xmlns:a16="http://schemas.microsoft.com/office/drawing/2014/main" id="{F96D5051-D0E1-4964-8DDC-4FA11390E03D}"/>
+                <a16:creationId xmlns:a16="http://schemas.microsoft.com/office/drawing/2014/main" id="{53D3AE28-741C-40F6-B467-D28470515528}"/>
               </a:ext>
             </a:extLst>
           </p:cNvPr>
@@ -1242,7 +1242,7 @@
           <p:cNvPr id="5" name="affiliations">
             <a:extLst xmlns:a="http://schemas.openxmlformats.org/drawingml/2006/main">
               <a:ext uri="{FF2B5EF4-FFF2-40B4-BE49-F238E27FC236}">
-                <a16:creationId xmlns:a16="http://schemas.microsoft.com/office/drawing/2014/main" id="{25ED812E-4298-461C-9EF3-4C21AA142999}"/>
+                <a16:creationId xmlns:a16="http://schemas.microsoft.com/office/drawing/2014/main" id="{9A0DD524-CC5E-4B1C-BCA4-2139AC2C33A3}"/>
               </a:ext>
             </a:extLst>
           </p:cNvPr>
@@ -1292,7 +1292,7 @@
           <p:cNvPr id="6" name="citation">
             <a:extLst xmlns:a="http://schemas.openxmlformats.org/drawingml/2006/main">
               <a:ext uri="{FF2B5EF4-FFF2-40B4-BE49-F238E27FC236}">
-                <a16:creationId xmlns:a16="http://schemas.microsoft.com/office/drawing/2014/main" id="{C6E90908-16BC-4F5C-AA52-1276A436F832}"/>
+                <a16:creationId xmlns:a16="http://schemas.microsoft.com/office/drawing/2014/main" id="{A6297583-C6A7-4EC3-B6E7-862B7618E809}"/>
               </a:ext>
             </a:extLst>
           </p:cNvPr>
@@ -1342,7 +1342,7 @@
           <p:cNvPr id="7" name="logo-slot-institution-logo">
             <a:extLst xmlns:a="http://schemas.openxmlformats.org/drawingml/2006/main">
               <a:ext uri="{FF2B5EF4-FFF2-40B4-BE49-F238E27FC236}">
-                <a16:creationId xmlns:a16="http://schemas.microsoft.com/office/drawing/2014/main" id="{288FE6FC-8B91-41A4-977C-087947FA2514}"/>
+                <a16:creationId xmlns:a16="http://schemas.microsoft.com/office/drawing/2014/main" id="{B16B37EE-A788-4A56-AEBD-4A44054289B0}"/>
               </a:ext>
             </a:extLst>
           </p:cNvPr>
@@ -1377,7 +1377,7 @@
           <p:cNvPr id="8" name="logo-placeholder-institution-logo">
             <a:extLst xmlns:a="http://schemas.openxmlformats.org/drawingml/2006/main">
               <a:ext uri="{FF2B5EF4-FFF2-40B4-BE49-F238E27FC236}">
-                <a16:creationId xmlns:a16="http://schemas.microsoft.com/office/drawing/2014/main" id="{FACAF53D-4D7E-476E-A257-135A6441B717}"/>
+                <a16:creationId xmlns:a16="http://schemas.microsoft.com/office/drawing/2014/main" id="{67A38E06-369B-4C83-802D-FAE3E218E7A0}"/>
               </a:ext>
             </a:extLst>
           </p:cNvPr>
@@ -1427,7 +1427,7 @@
           <p:cNvPr id="9" name="header-summary">
             <a:extLst xmlns:a="http://schemas.openxmlformats.org/drawingml/2006/main">
               <a:ext uri="{FF2B5EF4-FFF2-40B4-BE49-F238E27FC236}">
-                <a16:creationId xmlns:a16="http://schemas.microsoft.com/office/drawing/2014/main" id="{3E77800F-4FC4-4262-BDE1-F3CB65626C0A}"/>
+                <a16:creationId xmlns:a16="http://schemas.microsoft.com/office/drawing/2014/main" id="{DAF86BDE-F04A-45DC-9DFF-366121903F64}"/>
               </a:ext>
             </a:extLst>
           </p:cNvPr>
@@ -1460,7 +1460,7 @@
           <p:cNvPr id="10" name="header-metric-1-value">
             <a:extLst xmlns:a="http://schemas.openxmlformats.org/drawingml/2006/main">
               <a:ext uri="{FF2B5EF4-FFF2-40B4-BE49-F238E27FC236}">
-                <a16:creationId xmlns:a16="http://schemas.microsoft.com/office/drawing/2014/main" id="{0656C53C-17ED-4A4E-A18A-45B205D9D714}"/>
+                <a16:creationId xmlns:a16="http://schemas.microsoft.com/office/drawing/2014/main" id="{E5E383CC-83CD-4A6C-9C82-2D5D1DDF34FB}"/>
               </a:ext>
             </a:extLst>
           </p:cNvPr>
@@ -1510,18 +1510,18 @@
           <p:cNvPr id="11" name="header-metric-1-label">
             <a:extLst xmlns:a="http://schemas.openxmlformats.org/drawingml/2006/main">
               <a:ext uri="{FF2B5EF4-FFF2-40B4-BE49-F238E27FC236}">
-                <a16:creationId xmlns:a16="http://schemas.microsoft.com/office/drawing/2014/main" id="{1E6C0B5A-5CA4-41FF-B587-7026124BD4D7}"/>
-              </a:ext>
-            </a:extLst>
-          </p:cNvPr>
-          <p:cNvSpPr>
-            <a:spLocks xmlns:a="http://schemas.openxmlformats.org/drawingml/2006/main" noGrp="1"/>
-          </p:cNvSpPr>
-          <p:nvPr/>
-        </p:nvSpPr>
-        <p:spPr>
-          <a:xfrm xmlns:a="http://schemas.openxmlformats.org/drawingml/2006/main">
-            <a:off x="33597180" y="3334295"/>
+                <a16:creationId xmlns:a16="http://schemas.microsoft.com/office/drawing/2014/main" id="{12A70181-82BA-416B-B8BD-DDB8F0CFC8F6}"/>
+              </a:ext>
+            </a:extLst>
+          </p:cNvPr>
+          <p:cNvSpPr>
+            <a:spLocks xmlns:a="http://schemas.openxmlformats.org/drawingml/2006/main" noGrp="1"/>
+          </p:cNvSpPr>
+          <p:nvPr/>
+        </p:nvSpPr>
+        <p:spPr>
+          <a:xfrm xmlns:a="http://schemas.openxmlformats.org/drawingml/2006/main">
+            <a:off x="33597180" y="3292875"/>
             <a:ext cx="2539322" cy="911236"/>
           </a:xfrm>
           <a:prstGeom xmlns:a="http://schemas.openxmlformats.org/drawingml/2006/main" prst="rect">
@@ -1550,7 +1550,7 @@
                   <a:srgbClr val="102A43"/>
                 </a:solidFill>
               </a:rPr>
-              <a:t>signature features</a:t>
+              <a:t>primary observations</a:t>
             </a:r>
           </a:p>
         </p:txBody>
@@ -1560,7 +1560,7 @@
           <p:cNvPr id="12" name="header-metric-2-value">
             <a:extLst xmlns:a="http://schemas.openxmlformats.org/drawingml/2006/main">
               <a:ext uri="{FF2B5EF4-FFF2-40B4-BE49-F238E27FC236}">
-                <a16:creationId xmlns:a16="http://schemas.microsoft.com/office/drawing/2014/main" id="{6AA7AFA3-BCF3-423F-9D0F-9B49ECCC7A2C}"/>
+                <a16:creationId xmlns:a16="http://schemas.microsoft.com/office/drawing/2014/main" id="{43960DF2-5D36-49BF-AFBC-1320CB6DB000}"/>
               </a:ext>
             </a:extLst>
           </p:cNvPr>
@@ -1610,18 +1610,18 @@
           <p:cNvPr id="13" name="header-metric-2-label">
             <a:extLst xmlns:a="http://schemas.openxmlformats.org/drawingml/2006/main">
               <a:ext uri="{FF2B5EF4-FFF2-40B4-BE49-F238E27FC236}">
-                <a16:creationId xmlns:a16="http://schemas.microsoft.com/office/drawing/2014/main" id="{CA9B0B57-9FD1-4AEB-9E92-CE1B2EE92510}"/>
-              </a:ext>
-            </a:extLst>
-          </p:cNvPr>
-          <p:cNvSpPr>
-            <a:spLocks xmlns:a="http://schemas.openxmlformats.org/drawingml/2006/main" noGrp="1"/>
-          </p:cNvSpPr>
-          <p:nvPr/>
-        </p:nvSpPr>
-        <p:spPr>
-          <a:xfrm xmlns:a="http://schemas.openxmlformats.org/drawingml/2006/main">
-            <a:off x="36527167" y="3334295"/>
+                <a16:creationId xmlns:a16="http://schemas.microsoft.com/office/drawing/2014/main" id="{6C67439A-7807-4549-AE6C-671920C6A162}"/>
+              </a:ext>
+            </a:extLst>
+          </p:cNvPr>
+          <p:cNvSpPr>
+            <a:spLocks xmlns:a="http://schemas.openxmlformats.org/drawingml/2006/main" noGrp="1"/>
+          </p:cNvSpPr>
+          <p:nvPr/>
+        </p:nvSpPr>
+        <p:spPr>
+          <a:xfrm xmlns:a="http://schemas.openxmlformats.org/drawingml/2006/main">
+            <a:off x="36527167" y="3292875"/>
             <a:ext cx="2539322" cy="911236"/>
           </a:xfrm>
           <a:prstGeom xmlns:a="http://schemas.openxmlformats.org/drawingml/2006/main" prst="rect">
@@ -1650,7 +1650,7 @@
                   <a:srgbClr val="102A43"/>
                 </a:solidFill>
               </a:rPr>
-              <a:t>discovery samples</a:t>
+              <a:t>analysis samples</a:t>
             </a:r>
           </a:p>
         </p:txBody>
@@ -1660,7 +1660,7 @@
           <p:cNvPr id="14" name="header-metric-3-value">
             <a:extLst xmlns:a="http://schemas.openxmlformats.org/drawingml/2006/main">
               <a:ext uri="{FF2B5EF4-FFF2-40B4-BE49-F238E27FC236}">
-                <a16:creationId xmlns:a16="http://schemas.microsoft.com/office/drawing/2014/main" id="{3E913EBF-0740-496D-9A19-661574246FE3}"/>
+                <a16:creationId xmlns:a16="http://schemas.microsoft.com/office/drawing/2014/main" id="{91FBF501-6417-44FC-872A-52FBE2FC867C}"/>
               </a:ext>
             </a:extLst>
           </p:cNvPr>
@@ -1710,18 +1710,18 @@
           <p:cNvPr id="15" name="header-metric-3-label">
             <a:extLst xmlns:a="http://schemas.openxmlformats.org/drawingml/2006/main">
               <a:ext uri="{FF2B5EF4-FFF2-40B4-BE49-F238E27FC236}">
-                <a16:creationId xmlns:a16="http://schemas.microsoft.com/office/drawing/2014/main" id="{280EA751-7ECA-4C56-9788-F0BD36E5225A}"/>
-              </a:ext>
-            </a:extLst>
-          </p:cNvPr>
-          <p:cNvSpPr>
-            <a:spLocks xmlns:a="http://schemas.openxmlformats.org/drawingml/2006/main" noGrp="1"/>
-          </p:cNvSpPr>
-          <p:nvPr/>
-        </p:nvSpPr>
-        <p:spPr>
-          <a:xfrm xmlns:a="http://schemas.openxmlformats.org/drawingml/2006/main">
-            <a:off x="39457154" y="3334295"/>
+                <a16:creationId xmlns:a16="http://schemas.microsoft.com/office/drawing/2014/main" id="{1C15A4F4-B019-4D23-B61D-115BA3DA8731}"/>
+              </a:ext>
+            </a:extLst>
+          </p:cNvPr>
+          <p:cNvSpPr>
+            <a:spLocks xmlns:a="http://schemas.openxmlformats.org/drawingml/2006/main" noGrp="1"/>
+          </p:cNvSpPr>
+          <p:nvPr/>
+        </p:nvSpPr>
+        <p:spPr>
+          <a:xfrm xmlns:a="http://schemas.openxmlformats.org/drawingml/2006/main">
+            <a:off x="39457154" y="3292875"/>
             <a:ext cx="2539322" cy="911236"/>
           </a:xfrm>
           <a:prstGeom xmlns:a="http://schemas.openxmlformats.org/drawingml/2006/main" prst="rect">
@@ -1750,7 +1750,7 @@
                   <a:srgbClr val="102A43"/>
                 </a:solidFill>
               </a:rPr>
-              <a:t>validation cohorts</a:t>
+              <a:t>validation units</a:t>
             </a:r>
           </a:p>
         </p:txBody>
@@ -1760,7 +1760,7 @@
           <p:cNvPr id="16" name="question-title">
             <a:extLst xmlns:a="http://schemas.openxmlformats.org/drawingml/2006/main">
               <a:ext uri="{FF2B5EF4-FFF2-40B4-BE49-F238E27FC236}">
-                <a16:creationId xmlns:a16="http://schemas.microsoft.com/office/drawing/2014/main" id="{BEC089E0-7F47-4C64-B046-63DB53ABB3C9}"/>
+                <a16:creationId xmlns:a16="http://schemas.microsoft.com/office/drawing/2014/main" id="{03E07F7B-004B-46EE-920D-376881A7E831}"/>
               </a:ext>
             </a:extLst>
           </p:cNvPr>
@@ -1800,7 +1800,7 @@
                   <a:srgbClr val="0F5F73"/>
                 </a:solidFill>
               </a:rPr>
-              <a:t>Research question</a:t>
+              <a:t>Biological question</a:t>
             </a:r>
           </a:p>
         </p:txBody>
@@ -1810,7 +1810,7 @@
           <p:cNvPr id="17" name="question-rule">
             <a:extLst xmlns:a="http://schemas.openxmlformats.org/drawingml/2006/main">
               <a:ext uri="{FF2B5EF4-FFF2-40B4-BE49-F238E27FC236}">
-                <a16:creationId xmlns:a16="http://schemas.microsoft.com/office/drawing/2014/main" id="{B506CDC1-C6F0-4536-A9C9-1282C4AF682E}"/>
+                <a16:creationId xmlns:a16="http://schemas.microsoft.com/office/drawing/2014/main" id="{7433157A-C14F-4EEB-A915-89C88ABEA603}"/>
               </a:ext>
             </a:extLst>
           </p:cNvPr>
@@ -1843,7 +1843,7 @@
           <p:cNvPr id="18" name="research-question">
             <a:extLst xmlns:a="http://schemas.openxmlformats.org/drawingml/2006/main">
               <a:ext uri="{FF2B5EF4-FFF2-40B4-BE49-F238E27FC236}">
-                <a16:creationId xmlns:a16="http://schemas.microsoft.com/office/drawing/2014/main" id="{A57F753F-1257-4D3C-A9B1-880252D914BB}"/>
+                <a16:creationId xmlns:a16="http://schemas.microsoft.com/office/drawing/2014/main" id="{507DEAF6-C85B-47A3-A1EE-2DE8CD8ABD87}"/>
               </a:ext>
             </a:extLst>
           </p:cNvPr>
@@ -1855,7 +1855,7 @@
         <p:spPr>
           <a:xfrm xmlns:a="http://schemas.openxmlformats.org/drawingml/2006/main">
             <a:off x="1367327" y="7062079"/>
-            <a:ext cx="11915279" cy="2433414"/>
+            <a:ext cx="11915279" cy="2278090"/>
           </a:xfrm>
           <a:prstGeom xmlns:a="http://schemas.openxmlformats.org/drawingml/2006/main" prst="rect">
             <a:avLst/>
@@ -1883,7 +1883,7 @@
                   <a:srgbClr val="102A43"/>
                 </a:solidFill>
               </a:rPr>
-              <a:t>State the biological or clinical question in two concise sentences.</a:t>
+              <a:t>State the scientific question in two concise sentences.</a:t>
             </a:r>
           </a:p>
         </p:txBody>
@@ -1893,7 +1893,7 @@
           <p:cNvPr id="19" name="question-evidence">
             <a:extLst xmlns:a="http://schemas.openxmlformats.org/drawingml/2006/main">
               <a:ext uri="{FF2B5EF4-FFF2-40B4-BE49-F238E27FC236}">
-                <a16:creationId xmlns:a16="http://schemas.microsoft.com/office/drawing/2014/main" id="{08208101-9C55-437B-BD5E-5683BAC99B8C}"/>
+                <a16:creationId xmlns:a16="http://schemas.microsoft.com/office/drawing/2014/main" id="{7207C035-F106-480A-A67C-DCAA420118E0}"/>
               </a:ext>
             </a:extLst>
           </p:cNvPr>
@@ -1921,14 +1921,14 @@
           <a:lstStyle xmlns:a="http://schemas.openxmlformats.org/drawingml/2006/main"/>
           <a:p xmlns:a="http://schemas.openxmlformats.org/drawingml/2006/main">
             <a:pPr>
-              <a:defRPr sz="1923" i="1">
+              <a:defRPr sz="1923">
                 <a:solidFill>
                   <a:srgbClr val="2C8C99"/>
                 </a:solidFill>
               </a:defRPr>
             </a:pPr>
             <a:r>
-              <a:rPr sz="1923" i="1">
+              <a:rPr sz="1923">
                 <a:solidFill>
                   <a:srgbClr val="2C8C99"/>
                 </a:solidFill>
@@ -1943,7 +1943,7 @@
           <p:cNvPr id="20" name="pipeline-title">
             <a:extLst xmlns:a="http://schemas.openxmlformats.org/drawingml/2006/main">
               <a:ext uri="{FF2B5EF4-FFF2-40B4-BE49-F238E27FC236}">
-                <a16:creationId xmlns:a16="http://schemas.microsoft.com/office/drawing/2014/main" id="{0F49C46B-2ED3-4238-85F6-4D01F7D74B18}"/>
+                <a16:creationId xmlns:a16="http://schemas.microsoft.com/office/drawing/2014/main" id="{F97B645C-424A-4148-91E3-66DC0D343247}"/>
               </a:ext>
             </a:extLst>
           </p:cNvPr>
@@ -1993,7 +1993,7 @@
           <p:cNvPr id="21" name="pipeline-rule">
             <a:extLst xmlns:a="http://schemas.openxmlformats.org/drawingml/2006/main">
               <a:ext uri="{FF2B5EF4-FFF2-40B4-BE49-F238E27FC236}">
-                <a16:creationId xmlns:a16="http://schemas.microsoft.com/office/drawing/2014/main" id="{F7C567F8-2C15-453C-9185-63502F3A8CD7}"/>
+                <a16:creationId xmlns:a16="http://schemas.microsoft.com/office/drawing/2014/main" id="{119BE6BA-BC6A-40C2-9F5C-A3F0EC1445C7}"/>
               </a:ext>
             </a:extLst>
           </p:cNvPr>
@@ -2026,7 +2026,7 @@
           <p:cNvPr id="22" name="pipeline-1-number-bg">
             <a:extLst xmlns:a="http://schemas.openxmlformats.org/drawingml/2006/main">
               <a:ext uri="{FF2B5EF4-FFF2-40B4-BE49-F238E27FC236}">
-                <a16:creationId xmlns:a16="http://schemas.microsoft.com/office/drawing/2014/main" id="{96E4DCBF-1EDA-4ED1-A053-A394EC3CB882}"/>
+                <a16:creationId xmlns:a16="http://schemas.microsoft.com/office/drawing/2014/main" id="{61A61BB7-D185-4D06-B874-6197757326D2}"/>
               </a:ext>
             </a:extLst>
           </p:cNvPr>
@@ -2059,7 +2059,7 @@
           <p:cNvPr id="23" name="pipeline-1-number">
             <a:extLst xmlns:a="http://schemas.openxmlformats.org/drawingml/2006/main">
               <a:ext uri="{FF2B5EF4-FFF2-40B4-BE49-F238E27FC236}">
-                <a16:creationId xmlns:a16="http://schemas.microsoft.com/office/drawing/2014/main" id="{AEB266DA-0D3E-4856-B04B-E2F0053709D4}"/>
+                <a16:creationId xmlns:a16="http://schemas.microsoft.com/office/drawing/2014/main" id="{08A902C8-3556-4D4B-B79B-6360C3BD7940}"/>
               </a:ext>
             </a:extLst>
           </p:cNvPr>
@@ -2109,7 +2109,7 @@
           <p:cNvPr id="24" name="pipeline-1-text">
             <a:extLst xmlns:a="http://schemas.openxmlformats.org/drawingml/2006/main">
               <a:ext uri="{FF2B5EF4-FFF2-40B4-BE49-F238E27FC236}">
-                <a16:creationId xmlns:a16="http://schemas.microsoft.com/office/drawing/2014/main" id="{BF2C1621-BA8D-4043-A4EA-8F12F1018E7A}"/>
+                <a16:creationId xmlns:a16="http://schemas.microsoft.com/office/drawing/2014/main" id="{F686BBD3-604B-40C6-A379-A209715E9479}"/>
               </a:ext>
             </a:extLst>
           </p:cNvPr>
@@ -2137,14 +2137,14 @@
           <a:lstStyle xmlns:a="http://schemas.openxmlformats.org/drawingml/2006/main"/>
           <a:p xmlns:a="http://schemas.openxmlformats.org/drawingml/2006/main">
             <a:pPr>
-              <a:defRPr sz="2922" b="1">
-                <a:solidFill>
-                  <a:srgbClr val="102A43"/>
-                </a:solidFill>
-              </a:defRPr>
-            </a:pPr>
-            <a:r>
-              <a:rPr sz="2922" b="1">
+              <a:defRPr sz="2922">
+                <a:solidFill>
+                  <a:srgbClr val="102A43"/>
+                </a:solidFill>
+              </a:defRPr>
+            </a:pPr>
+            <a:r>
+              <a:rPr sz="2922">
                 <a:solidFill>
                   <a:srgbClr val="102A43"/>
                 </a:solidFill>
@@ -2159,7 +2159,7 @@
           <p:cNvPr id="25" name="pipeline-2-number-bg">
             <a:extLst xmlns:a="http://schemas.openxmlformats.org/drawingml/2006/main">
               <a:ext uri="{FF2B5EF4-FFF2-40B4-BE49-F238E27FC236}">
-                <a16:creationId xmlns:a16="http://schemas.microsoft.com/office/drawing/2014/main" id="{C343C1E2-3E97-4D7B-AD3F-057145E2A556}"/>
+                <a16:creationId xmlns:a16="http://schemas.microsoft.com/office/drawing/2014/main" id="{F046A74D-95A1-4603-AAC3-6A7632439D68}"/>
               </a:ext>
             </a:extLst>
           </p:cNvPr>
@@ -2192,7 +2192,7 @@
           <p:cNvPr id="26" name="pipeline-2-number">
             <a:extLst xmlns:a="http://schemas.openxmlformats.org/drawingml/2006/main">
               <a:ext uri="{FF2B5EF4-FFF2-40B4-BE49-F238E27FC236}">
-                <a16:creationId xmlns:a16="http://schemas.microsoft.com/office/drawing/2014/main" id="{B6627B13-D707-4EF0-876C-8C3710490C3E}"/>
+                <a16:creationId xmlns:a16="http://schemas.microsoft.com/office/drawing/2014/main" id="{ADF0BF7F-945B-4078-BBE5-A72518BFDBC4}"/>
               </a:ext>
             </a:extLst>
           </p:cNvPr>
@@ -2242,7 +2242,7 @@
           <p:cNvPr id="27" name="pipeline-2-text">
             <a:extLst xmlns:a="http://schemas.openxmlformats.org/drawingml/2006/main">
               <a:ext uri="{FF2B5EF4-FFF2-40B4-BE49-F238E27FC236}">
-                <a16:creationId xmlns:a16="http://schemas.microsoft.com/office/drawing/2014/main" id="{B82A3FBE-FF86-4560-98F3-04C536F91B59}"/>
+                <a16:creationId xmlns:a16="http://schemas.microsoft.com/office/drawing/2014/main" id="{397370B1-92CD-444C-A38C-002831C335E7}"/>
               </a:ext>
             </a:extLst>
           </p:cNvPr>
@@ -2270,14 +2270,14 @@
           <a:lstStyle xmlns:a="http://schemas.openxmlformats.org/drawingml/2006/main"/>
           <a:p xmlns:a="http://schemas.openxmlformats.org/drawingml/2006/main">
             <a:pPr>
-              <a:defRPr sz="2922" b="1">
-                <a:solidFill>
-                  <a:srgbClr val="102A43"/>
-                </a:solidFill>
-              </a:defRPr>
-            </a:pPr>
-            <a:r>
-              <a:rPr sz="2922" b="1">
+              <a:defRPr sz="2922">
+                <a:solidFill>
+                  <a:srgbClr val="102A43"/>
+                </a:solidFill>
+              </a:defRPr>
+            </a:pPr>
+            <a:r>
+              <a:rPr sz="2922">
                 <a:solidFill>
                   <a:srgbClr val="102A43"/>
                 </a:solidFill>
@@ -2292,7 +2292,7 @@
           <p:cNvPr id="28" name="pipeline-3-number-bg">
             <a:extLst xmlns:a="http://schemas.openxmlformats.org/drawingml/2006/main">
               <a:ext uri="{FF2B5EF4-FFF2-40B4-BE49-F238E27FC236}">
-                <a16:creationId xmlns:a16="http://schemas.microsoft.com/office/drawing/2014/main" id="{3E620B57-7E1B-4EB7-81DB-216497D4BBC4}"/>
+                <a16:creationId xmlns:a16="http://schemas.microsoft.com/office/drawing/2014/main" id="{A75F54B1-35A1-47F4-80E9-58A3F119B1AD}"/>
               </a:ext>
             </a:extLst>
           </p:cNvPr>
@@ -2325,7 +2325,7 @@
           <p:cNvPr id="29" name="pipeline-3-number">
             <a:extLst xmlns:a="http://schemas.openxmlformats.org/drawingml/2006/main">
               <a:ext uri="{FF2B5EF4-FFF2-40B4-BE49-F238E27FC236}">
-                <a16:creationId xmlns:a16="http://schemas.microsoft.com/office/drawing/2014/main" id="{1DEA2DB3-0845-454A-97B7-51A0BA889082}"/>
+                <a16:creationId xmlns:a16="http://schemas.microsoft.com/office/drawing/2014/main" id="{DB07A51A-995C-4E7E-88ED-661F2788129A}"/>
               </a:ext>
             </a:extLst>
           </p:cNvPr>
@@ -2375,7 +2375,7 @@
           <p:cNvPr id="30" name="pipeline-3-text">
             <a:extLst xmlns:a="http://schemas.openxmlformats.org/drawingml/2006/main">
               <a:ext uri="{FF2B5EF4-FFF2-40B4-BE49-F238E27FC236}">
-                <a16:creationId xmlns:a16="http://schemas.microsoft.com/office/drawing/2014/main" id="{84B70C6D-AE5F-4B1B-9F52-46582DE6BF55}"/>
+                <a16:creationId xmlns:a16="http://schemas.microsoft.com/office/drawing/2014/main" id="{F653ABFE-3214-487A-9E24-B55F32DFBF0F}"/>
               </a:ext>
             </a:extLst>
           </p:cNvPr>
@@ -2403,14 +2403,14 @@
           <a:lstStyle xmlns:a="http://schemas.openxmlformats.org/drawingml/2006/main"/>
           <a:p xmlns:a="http://schemas.openxmlformats.org/drawingml/2006/main">
             <a:pPr>
-              <a:defRPr sz="2922" b="1">
-                <a:solidFill>
-                  <a:srgbClr val="102A43"/>
-                </a:solidFill>
-              </a:defRPr>
-            </a:pPr>
-            <a:r>
-              <a:rPr sz="2922" b="1">
+              <a:defRPr sz="2922">
+                <a:solidFill>
+                  <a:srgbClr val="102A43"/>
+                </a:solidFill>
+              </a:defRPr>
+            </a:pPr>
+            <a:r>
+              <a:rPr sz="2922">
                 <a:solidFill>
                   <a:srgbClr val="102A43"/>
                 </a:solidFill>
@@ -2425,7 +2425,7 @@
           <p:cNvPr id="31" name="pipeline-4-number-bg">
             <a:extLst xmlns:a="http://schemas.openxmlformats.org/drawingml/2006/main">
               <a:ext uri="{FF2B5EF4-FFF2-40B4-BE49-F238E27FC236}">
-                <a16:creationId xmlns:a16="http://schemas.microsoft.com/office/drawing/2014/main" id="{51EBAE2F-49C4-4305-863E-4069118E7380}"/>
+                <a16:creationId xmlns:a16="http://schemas.microsoft.com/office/drawing/2014/main" id="{1F72E918-DC14-4337-8C03-C5E115C8820C}"/>
               </a:ext>
             </a:extLst>
           </p:cNvPr>
@@ -2458,7 +2458,7 @@
           <p:cNvPr id="32" name="pipeline-4-number">
             <a:extLst xmlns:a="http://schemas.openxmlformats.org/drawingml/2006/main">
               <a:ext uri="{FF2B5EF4-FFF2-40B4-BE49-F238E27FC236}">
-                <a16:creationId xmlns:a16="http://schemas.microsoft.com/office/drawing/2014/main" id="{C5FAE99A-AF13-45FE-9230-705E27E26DC4}"/>
+                <a16:creationId xmlns:a16="http://schemas.microsoft.com/office/drawing/2014/main" id="{9F930837-AE52-4E79-9BD8-406CFF50C517}"/>
               </a:ext>
             </a:extLst>
           </p:cNvPr>
@@ -2508,7 +2508,7 @@
           <p:cNvPr id="33" name="pipeline-4-text">
             <a:extLst xmlns:a="http://schemas.openxmlformats.org/drawingml/2006/main">
               <a:ext uri="{FF2B5EF4-FFF2-40B4-BE49-F238E27FC236}">
-                <a16:creationId xmlns:a16="http://schemas.microsoft.com/office/drawing/2014/main" id="{3C313228-E501-4EC6-A6AE-684465EB4802}"/>
+                <a16:creationId xmlns:a16="http://schemas.microsoft.com/office/drawing/2014/main" id="{84835768-1720-4548-B546-605F8F3CBB7F}"/>
               </a:ext>
             </a:extLst>
           </p:cNvPr>
@@ -2536,14 +2536,14 @@
           <a:lstStyle xmlns:a="http://schemas.openxmlformats.org/drawingml/2006/main"/>
           <a:p xmlns:a="http://schemas.openxmlformats.org/drawingml/2006/main">
             <a:pPr>
-              <a:defRPr sz="2922" b="1">
-                <a:solidFill>
-                  <a:srgbClr val="102A43"/>
-                </a:solidFill>
-              </a:defRPr>
-            </a:pPr>
-            <a:r>
-              <a:rPr sz="2922" b="1">
+              <a:defRPr sz="2922">
+                <a:solidFill>
+                  <a:srgbClr val="102A43"/>
+                </a:solidFill>
+              </a:defRPr>
+            </a:pPr>
+            <a:r>
+              <a:rPr sz="2922">
                 <a:solidFill>
                   <a:srgbClr val="102A43"/>
                 </a:solidFill>
@@ -2558,7 +2558,7 @@
           <p:cNvPr id="34" name="dataset-panel">
             <a:extLst xmlns:a="http://schemas.openxmlformats.org/drawingml/2006/main">
               <a:ext uri="{FF2B5EF4-FFF2-40B4-BE49-F238E27FC236}">
-                <a16:creationId xmlns:a16="http://schemas.microsoft.com/office/drawing/2014/main" id="{4C7A70BE-8F03-43B5-B6DC-196D32B7FA3E}"/>
+                <a16:creationId xmlns:a16="http://schemas.microsoft.com/office/drawing/2014/main" id="{B6D34E2B-3766-420D-94DE-56965A5FAA6D}"/>
               </a:ext>
             </a:extLst>
           </p:cNvPr>
@@ -2593,7 +2593,7 @@
           <p:cNvPr id="35" name="dataset-kicker">
             <a:extLst xmlns:a="http://schemas.openxmlformats.org/drawingml/2006/main">
               <a:ext uri="{FF2B5EF4-FFF2-40B4-BE49-F238E27FC236}">
-                <a16:creationId xmlns:a16="http://schemas.microsoft.com/office/drawing/2014/main" id="{E13834D2-64F7-40A9-BF87-FB6CCE310808}"/>
+                <a16:creationId xmlns:a16="http://schemas.microsoft.com/office/drawing/2014/main" id="{16039E8A-4749-4209-834F-977338DB9B11}"/>
               </a:ext>
             </a:extLst>
           </p:cNvPr>
@@ -2643,7 +2643,7 @@
           <p:cNvPr id="36" name="datasets">
             <a:extLst xmlns:a="http://schemas.openxmlformats.org/drawingml/2006/main">
               <a:ext uri="{FF2B5EF4-FFF2-40B4-BE49-F238E27FC236}">
-                <a16:creationId xmlns:a16="http://schemas.microsoft.com/office/drawing/2014/main" id="{225A5A68-2D80-4257-B823-DE0785DBBA65}"/>
+                <a16:creationId xmlns:a16="http://schemas.microsoft.com/office/drawing/2014/main" id="{E92BC317-9AFE-411F-BFD2-2AE61C8355A8}"/>
               </a:ext>
             </a:extLst>
           </p:cNvPr>
@@ -2655,7 +2655,7 @@
         <p:spPr>
           <a:xfrm xmlns:a="http://schemas.openxmlformats.org/drawingml/2006/main">
             <a:off x="1640793" y="15480657"/>
-            <a:ext cx="11368348" cy="2381640"/>
+            <a:ext cx="11368348" cy="2236670"/>
           </a:xfrm>
           <a:prstGeom xmlns:a="http://schemas.openxmlformats.org/drawingml/2006/main" prst="rect">
             <a:avLst/>
@@ -2683,7 +2683,7 @@
                   <a:srgbClr val="102A43"/>
                 </a:solidFill>
               </a:rPr>
-              <a:t>Discovery cohort</a:t>
+              <a:t>Discovery set</a:t>
             </a:r>
           </a:p>
           <a:p xmlns:a="http://schemas.openxmlformats.org/drawingml/2006/main">
@@ -2700,7 +2700,7 @@
                   <a:srgbClr val="102A43"/>
                 </a:solidFill>
               </a:rPr>
-              <a:t>Training and test split</a:t>
+              <a:t>Primary analysis</a:t>
             </a:r>
           </a:p>
           <a:p xmlns:a="http://schemas.openxmlformats.org/drawingml/2006/main">
@@ -2717,7 +2717,7 @@
                   <a:srgbClr val="102A43"/>
                 </a:solidFill>
               </a:rPr>
-              <a:t>External validation</a:t>
+              <a:t>Validation set</a:t>
             </a:r>
           </a:p>
           <a:p xmlns:a="http://schemas.openxmlformats.org/drawingml/2006/main">
@@ -2734,7 +2734,7 @@
                   <a:srgbClr val="102A43"/>
                 </a:solidFill>
               </a:rPr>
-              <a:t>Orthogonal validation</a:t>
+              <a:t>Sensitivity analysis</a:t>
             </a:r>
           </a:p>
         </p:txBody>
@@ -2744,7 +2744,7 @@
           <p:cNvPr id="37" name="dataset-evidence">
             <a:extLst xmlns:a="http://schemas.openxmlformats.org/drawingml/2006/main">
               <a:ext uri="{FF2B5EF4-FFF2-40B4-BE49-F238E27FC236}">
-                <a16:creationId xmlns:a16="http://schemas.microsoft.com/office/drawing/2014/main" id="{5510216A-EADD-45AC-B429-F3E206009857}"/>
+                <a16:creationId xmlns:a16="http://schemas.microsoft.com/office/drawing/2014/main" id="{B003DC99-F20E-4AD3-B3DE-049D92905B15}"/>
               </a:ext>
             </a:extLst>
           </p:cNvPr>
@@ -2772,14 +2772,14 @@
           <a:lstStyle xmlns:a="http://schemas.openxmlformats.org/drawingml/2006/main"/>
           <a:p xmlns:a="http://schemas.openxmlformats.org/drawingml/2006/main">
             <a:pPr>
-              <a:defRPr sz="1923" i="1">
+              <a:defRPr sz="1923">
                 <a:solidFill>
                   <a:srgbClr val="2C8C99"/>
                 </a:solidFill>
               </a:defRPr>
             </a:pPr>
             <a:r>
-              <a:rPr sz="1923" i="1">
+              <a:rPr sz="1923">
                 <a:solidFill>
                   <a:srgbClr val="2C8C99"/>
                 </a:solidFill>
@@ -2794,7 +2794,7 @@
           <p:cNvPr id="38" name="figure-one-heading-title">
             <a:extLst xmlns:a="http://schemas.openxmlformats.org/drawingml/2006/main">
               <a:ext uri="{FF2B5EF4-FFF2-40B4-BE49-F238E27FC236}">
-                <a16:creationId xmlns:a16="http://schemas.microsoft.com/office/drawing/2014/main" id="{7B95A64E-5055-4A1A-B583-D09D50B4BB09}"/>
+                <a16:creationId xmlns:a16="http://schemas.microsoft.com/office/drawing/2014/main" id="{70D75C5A-A8BF-4DAC-8A03-8417A04E99C0}"/>
               </a:ext>
             </a:extLst>
           </p:cNvPr>
@@ -2844,7 +2844,7 @@
           <p:cNvPr id="39" name="figure-one-heading-rule">
             <a:extLst xmlns:a="http://schemas.openxmlformats.org/drawingml/2006/main">
               <a:ext uri="{FF2B5EF4-FFF2-40B4-BE49-F238E27FC236}">
-                <a16:creationId xmlns:a16="http://schemas.microsoft.com/office/drawing/2014/main" id="{01CA6944-76A1-4ACD-ADB5-4D88C5B54786}"/>
+                <a16:creationId xmlns:a16="http://schemas.microsoft.com/office/drawing/2014/main" id="{E8B29CCE-CCA2-45C4-B4F6-0EA54579CEF9}"/>
               </a:ext>
             </a:extLst>
           </p:cNvPr>
@@ -2877,7 +2877,7 @@
           <p:cNvPr id="40" name="figure-one-frame">
             <a:extLst xmlns:a="http://schemas.openxmlformats.org/drawingml/2006/main">
               <a:ext uri="{FF2B5EF4-FFF2-40B4-BE49-F238E27FC236}">
-                <a16:creationId xmlns:a16="http://schemas.microsoft.com/office/drawing/2014/main" id="{EE75856C-0F65-4DB8-A918-93D2A0A7CFE4}"/>
+                <a16:creationId xmlns:a16="http://schemas.microsoft.com/office/drawing/2014/main" id="{5771B58C-ED7A-4A0F-8FE9-D7BD8DD2D2AB}"/>
               </a:ext>
             </a:extLst>
           </p:cNvPr>
@@ -2912,7 +2912,7 @@
           <p:cNvPr id="41" name="figure-one-placeholder">
             <a:extLst xmlns:a="http://schemas.openxmlformats.org/drawingml/2006/main">
               <a:ext uri="{FF2B5EF4-FFF2-40B4-BE49-F238E27FC236}">
-                <a16:creationId xmlns:a16="http://schemas.microsoft.com/office/drawing/2014/main" id="{DF3F5D53-07BD-4483-95ED-25E6621C4B32}"/>
+                <a16:creationId xmlns:a16="http://schemas.microsoft.com/office/drawing/2014/main" id="{5171247B-0BED-4535-AC89-7439BD63F332}"/>
               </a:ext>
             </a:extLst>
           </p:cNvPr>
@@ -2947,7 +2947,7 @@
           <p:cNvPr id="42" name="figure-one-placeholder-label">
             <a:extLst xmlns:a="http://schemas.openxmlformats.org/drawingml/2006/main">
               <a:ext uri="{FF2B5EF4-FFF2-40B4-BE49-F238E27FC236}">
-                <a16:creationId xmlns:a16="http://schemas.microsoft.com/office/drawing/2014/main" id="{AC5BD0CF-9927-4532-BF7C-1E538460D203}"/>
+                <a16:creationId xmlns:a16="http://schemas.microsoft.com/office/drawing/2014/main" id="{160E0A22-DCA3-4736-8881-D20D5A6D9039}"/>
               </a:ext>
             </a:extLst>
           </p:cNvPr>
@@ -2987,7 +2987,7 @@
                   <a:srgbClr val="2C8C99"/>
                 </a:solidFill>
               </a:rPr>
-              <a:t>SCIENTIFIC FIGURE</a:t>
+              <a:t>scientific figure</a:t>
             </a:r>
           </a:p>
         </p:txBody>
@@ -2997,7 +2997,7 @@
           <p:cNvPr id="43" name="figure-one-caption">
             <a:extLst xmlns:a="http://schemas.openxmlformats.org/drawingml/2006/main">
               <a:ext uri="{FF2B5EF4-FFF2-40B4-BE49-F238E27FC236}">
-                <a16:creationId xmlns:a16="http://schemas.microsoft.com/office/drawing/2014/main" id="{F689B21A-3618-4A26-8E58-2A983FB9CC15}"/>
+                <a16:creationId xmlns:a16="http://schemas.microsoft.com/office/drawing/2014/main" id="{BB63F5D4-EAD9-431B-9537-66C7A47DA45F}"/>
               </a:ext>
             </a:extLst>
           </p:cNvPr>
@@ -3009,7 +3009,7 @@
         <p:spPr>
           <a:xfrm xmlns:a="http://schemas.openxmlformats.org/drawingml/2006/main">
             <a:off x="1601726" y="29853334"/>
-            <a:ext cx="11446481" cy="434908"/>
+            <a:ext cx="11446481" cy="341713"/>
           </a:xfrm>
           <a:prstGeom xmlns:a="http://schemas.openxmlformats.org/drawingml/2006/main" prst="rect">
             <a:avLst/>
@@ -3037,7 +3037,7 @@
                   <a:srgbClr val="102A43"/>
                 </a:solidFill>
               </a:rPr>
-              <a:t>Figure caption</a:t>
+              <a:t>Scientific Figure caption</a:t>
             </a:r>
           </a:p>
         </p:txBody>
@@ -3047,18 +3047,18 @@
           <p:cNvPr id="44" name="figure-one-source">
             <a:extLst xmlns:a="http://schemas.openxmlformats.org/drawingml/2006/main">
               <a:ext uri="{FF2B5EF4-FFF2-40B4-BE49-F238E27FC236}">
-                <a16:creationId xmlns:a16="http://schemas.microsoft.com/office/drawing/2014/main" id="{AD4DE64F-E249-4C2A-8EC5-6BAEE84DE074}"/>
-              </a:ext>
-            </a:extLst>
-          </p:cNvPr>
-          <p:cNvSpPr>
-            <a:spLocks xmlns:a="http://schemas.openxmlformats.org/drawingml/2006/main" noGrp="1"/>
-          </p:cNvSpPr>
-          <p:nvPr/>
-        </p:nvSpPr>
-        <p:spPr>
-          <a:xfrm xmlns:a="http://schemas.openxmlformats.org/drawingml/2006/main">
-            <a:off x="1601726" y="30195047"/>
+                <a16:creationId xmlns:a16="http://schemas.microsoft.com/office/drawing/2014/main" id="{8EE31973-493E-4151-A46C-08935FF4E4A6}"/>
+              </a:ext>
+            </a:extLst>
+          </p:cNvPr>
+          <p:cNvSpPr>
+            <a:spLocks xmlns:a="http://schemas.openxmlformats.org/drawingml/2006/main" noGrp="1"/>
+          </p:cNvSpPr>
+          <p:nvPr/>
+        </p:nvSpPr>
+        <p:spPr>
+          <a:xfrm xmlns:a="http://schemas.openxmlformats.org/drawingml/2006/main">
+            <a:off x="1601726" y="30205402"/>
             <a:ext cx="11446481" cy="393488"/>
           </a:xfrm>
           <a:prstGeom xmlns:a="http://schemas.openxmlformats.org/drawingml/2006/main" prst="rect">
@@ -3075,14 +3075,14 @@
           <a:lstStyle xmlns:a="http://schemas.openxmlformats.org/drawingml/2006/main"/>
           <a:p xmlns:a="http://schemas.openxmlformats.org/drawingml/2006/main">
             <a:pPr>
-              <a:defRPr sz="1923" i="1">
+              <a:defRPr sz="1923">
                 <a:solidFill>
                   <a:srgbClr val="2C8C99"/>
                 </a:solidFill>
               </a:defRPr>
             </a:pPr>
             <a:r>
-              <a:rPr sz="1923" i="1">
+              <a:rPr sz="1923">
                 <a:solidFill>
                   <a:srgbClr val="2C8C99"/>
                 </a:solidFill>
@@ -3097,7 +3097,7 @@
           <p:cNvPr id="45" name="central-takeaway">
             <a:extLst xmlns:a="http://schemas.openxmlformats.org/drawingml/2006/main">
               <a:ext uri="{FF2B5EF4-FFF2-40B4-BE49-F238E27FC236}">
-                <a16:creationId xmlns:a16="http://schemas.microsoft.com/office/drawing/2014/main" id="{AD3764AD-E723-4E6B-BBF5-61F80E23464C}"/>
+                <a16:creationId xmlns:a16="http://schemas.microsoft.com/office/drawing/2014/main" id="{EF88A6EA-D726-4B85-892D-A99DB50D0A13}"/>
               </a:ext>
             </a:extLst>
           </p:cNvPr>
@@ -3130,7 +3130,7 @@
           <p:cNvPr id="46" name="central-takeaway-title">
             <a:extLst xmlns:a="http://schemas.openxmlformats.org/drawingml/2006/main">
               <a:ext uri="{FF2B5EF4-FFF2-40B4-BE49-F238E27FC236}">
-                <a16:creationId xmlns:a16="http://schemas.microsoft.com/office/drawing/2014/main" id="{A7CB2362-087C-42B7-B173-502FBE69DEA5}"/>
+                <a16:creationId xmlns:a16="http://schemas.microsoft.com/office/drawing/2014/main" id="{2A355975-34E4-4F20-9CD2-CBD1CF2D3E65}"/>
               </a:ext>
             </a:extLst>
           </p:cNvPr>
@@ -3180,7 +3180,7 @@
           <p:cNvPr id="47" name="central-takeaway-subtitle">
             <a:extLst xmlns:a="http://schemas.openxmlformats.org/drawingml/2006/main">
               <a:ext uri="{FF2B5EF4-FFF2-40B4-BE49-F238E27FC236}">
-                <a16:creationId xmlns:a16="http://schemas.microsoft.com/office/drawing/2014/main" id="{DD51CA4F-084F-4C34-81BA-965970D65E25}"/>
+                <a16:creationId xmlns:a16="http://schemas.microsoft.com/office/drawing/2014/main" id="{4908E5EA-6550-49B5-AA88-7ADBCCF2CD67}"/>
               </a:ext>
             </a:extLst>
           </p:cNvPr>
@@ -3230,7 +3230,7 @@
           <p:cNvPr id="48" name="takeaway-evidence">
             <a:extLst xmlns:a="http://schemas.openxmlformats.org/drawingml/2006/main">
               <a:ext uri="{FF2B5EF4-FFF2-40B4-BE49-F238E27FC236}">
-                <a16:creationId xmlns:a16="http://schemas.microsoft.com/office/drawing/2014/main" id="{1D1CBEB7-6B44-4358-AD43-07127DFB6651}"/>
+                <a16:creationId xmlns:a16="http://schemas.microsoft.com/office/drawing/2014/main" id="{9519E93C-85E7-4820-8B79-976FFEDCE3B5}"/>
               </a:ext>
             </a:extLst>
           </p:cNvPr>
@@ -3258,14 +3258,14 @@
           <a:lstStyle xmlns:a="http://schemas.openxmlformats.org/drawingml/2006/main"/>
           <a:p xmlns:a="http://schemas.openxmlformats.org/drawingml/2006/main">
             <a:pPr>
-              <a:defRPr sz="1923" i="1">
+              <a:defRPr sz="1923">
                 <a:solidFill>
                   <a:srgbClr val="2C8C99"/>
                 </a:solidFill>
               </a:defRPr>
             </a:pPr>
             <a:r>
-              <a:rPr sz="1923" i="1">
+              <a:rPr sz="1923">
                 <a:solidFill>
                   <a:srgbClr val="2C8C99"/>
                 </a:solidFill>
@@ -3280,7 +3280,7 @@
           <p:cNvPr id="49" name="figure-two-heading-title">
             <a:extLst xmlns:a="http://schemas.openxmlformats.org/drawingml/2006/main">
               <a:ext uri="{FF2B5EF4-FFF2-40B4-BE49-F238E27FC236}">
-                <a16:creationId xmlns:a16="http://schemas.microsoft.com/office/drawing/2014/main" id="{5AD37026-515C-4AB3-BC60-C46FB125A470}"/>
+                <a16:creationId xmlns:a16="http://schemas.microsoft.com/office/drawing/2014/main" id="{7C44466E-020E-4894-BA4D-CDDEF792DF77}"/>
               </a:ext>
             </a:extLst>
           </p:cNvPr>
@@ -3320,7 +3320,7 @@
                   <a:srgbClr val="0F5F73"/>
                 </a:solidFill>
               </a:rPr>
-              <a:t>Primary performance</a:t>
+              <a:t>Primary result</a:t>
             </a:r>
           </a:p>
         </p:txBody>
@@ -3330,7 +3330,7 @@
           <p:cNvPr id="50" name="figure-two-heading-rule">
             <a:extLst xmlns:a="http://schemas.openxmlformats.org/drawingml/2006/main">
               <a:ext uri="{FF2B5EF4-FFF2-40B4-BE49-F238E27FC236}">
-                <a16:creationId xmlns:a16="http://schemas.microsoft.com/office/drawing/2014/main" id="{10843A29-246A-4EDD-8A22-68AB8B1A019D}"/>
+                <a16:creationId xmlns:a16="http://schemas.microsoft.com/office/drawing/2014/main" id="{0612D8DA-7E47-41BA-B120-C0260AD20ED5}"/>
               </a:ext>
             </a:extLst>
           </p:cNvPr>
@@ -3363,7 +3363,7 @@
           <p:cNvPr id="51" name="figure-two-frame">
             <a:extLst xmlns:a="http://schemas.openxmlformats.org/drawingml/2006/main">
               <a:ext uri="{FF2B5EF4-FFF2-40B4-BE49-F238E27FC236}">
-                <a16:creationId xmlns:a16="http://schemas.microsoft.com/office/drawing/2014/main" id="{46EC079F-7736-41C5-88C5-BDFB1CD584A0}"/>
+                <a16:creationId xmlns:a16="http://schemas.microsoft.com/office/drawing/2014/main" id="{3E9C3E40-DFEF-4510-AB0E-F6575BA7C6BD}"/>
               </a:ext>
             </a:extLst>
           </p:cNvPr>
@@ -3398,7 +3398,7 @@
           <p:cNvPr id="52" name="figure-two-placeholder">
             <a:extLst xmlns:a="http://schemas.openxmlformats.org/drawingml/2006/main">
               <a:ext uri="{FF2B5EF4-FFF2-40B4-BE49-F238E27FC236}">
-                <a16:creationId xmlns:a16="http://schemas.microsoft.com/office/drawing/2014/main" id="{AEBB028A-BE28-4A5A-9BD1-280DBFB73C77}"/>
+                <a16:creationId xmlns:a16="http://schemas.microsoft.com/office/drawing/2014/main" id="{0886966F-144C-40E6-9B46-BACBA69C381D}"/>
               </a:ext>
             </a:extLst>
           </p:cNvPr>
@@ -3433,7 +3433,7 @@
           <p:cNvPr id="53" name="figure-two-placeholder-label">
             <a:extLst xmlns:a="http://schemas.openxmlformats.org/drawingml/2006/main">
               <a:ext uri="{FF2B5EF4-FFF2-40B4-BE49-F238E27FC236}">
-                <a16:creationId xmlns:a16="http://schemas.microsoft.com/office/drawing/2014/main" id="{8A19EBE0-D5BA-4CFD-93C0-38E2354B9E4B}"/>
+                <a16:creationId xmlns:a16="http://schemas.microsoft.com/office/drawing/2014/main" id="{78180973-59B1-4F9A-999D-8A125DD84AAE}"/>
               </a:ext>
             </a:extLst>
           </p:cNvPr>
@@ -3473,7 +3473,7 @@
                   <a:srgbClr val="2C8C99"/>
                 </a:solidFill>
               </a:rPr>
-              <a:t>SCIENTIFIC FIGURE</a:t>
+              <a:t>scientific figure</a:t>
             </a:r>
           </a:p>
         </p:txBody>
@@ -3483,7 +3483,7 @@
           <p:cNvPr id="54" name="figure-two-caption">
             <a:extLst xmlns:a="http://schemas.openxmlformats.org/drawingml/2006/main">
               <a:ext uri="{FF2B5EF4-FFF2-40B4-BE49-F238E27FC236}">
-                <a16:creationId xmlns:a16="http://schemas.microsoft.com/office/drawing/2014/main" id="{41273D8A-4092-4A3A-A217-2FE2D7176B8F}"/>
+                <a16:creationId xmlns:a16="http://schemas.microsoft.com/office/drawing/2014/main" id="{2DD73C9C-FDCC-4730-9EB7-55B5DEC3ACF4}"/>
               </a:ext>
             </a:extLst>
           </p:cNvPr>
@@ -3495,7 +3495,7 @@
         <p:spPr>
           <a:xfrm xmlns:a="http://schemas.openxmlformats.org/drawingml/2006/main">
             <a:off x="14103002" y="23381487"/>
-            <a:ext cx="13546305" cy="434908"/>
+            <a:ext cx="13546305" cy="341713"/>
           </a:xfrm>
           <a:prstGeom xmlns:a="http://schemas.openxmlformats.org/drawingml/2006/main" prst="rect">
             <a:avLst/>
@@ -3523,7 +3523,7 @@
                   <a:srgbClr val="102A43"/>
                 </a:solidFill>
               </a:rPr>
-              <a:t>Figure caption</a:t>
+              <a:t>Scientific Figure caption</a:t>
             </a:r>
           </a:p>
         </p:txBody>
@@ -3533,18 +3533,18 @@
           <p:cNvPr id="55" name="figure-two-source">
             <a:extLst xmlns:a="http://schemas.openxmlformats.org/drawingml/2006/main">
               <a:ext uri="{FF2B5EF4-FFF2-40B4-BE49-F238E27FC236}">
-                <a16:creationId xmlns:a16="http://schemas.microsoft.com/office/drawing/2014/main" id="{F202A2E0-0539-4BC1-A7F1-932BA93EDD93}"/>
-              </a:ext>
-            </a:extLst>
-          </p:cNvPr>
-          <p:cNvSpPr>
-            <a:spLocks xmlns:a="http://schemas.openxmlformats.org/drawingml/2006/main" noGrp="1"/>
-          </p:cNvSpPr>
-          <p:nvPr/>
-        </p:nvSpPr>
-        <p:spPr>
-          <a:xfrm xmlns:a="http://schemas.openxmlformats.org/drawingml/2006/main">
-            <a:off x="14103002" y="23723201"/>
+                <a16:creationId xmlns:a16="http://schemas.microsoft.com/office/drawing/2014/main" id="{A845D3B3-69BE-431C-905F-B6F3CF1DD1CA}"/>
+              </a:ext>
+            </a:extLst>
+          </p:cNvPr>
+          <p:cNvSpPr>
+            <a:spLocks xmlns:a="http://schemas.openxmlformats.org/drawingml/2006/main" noGrp="1"/>
+          </p:cNvSpPr>
+          <p:nvPr/>
+        </p:nvSpPr>
+        <p:spPr>
+          <a:xfrm xmlns:a="http://schemas.openxmlformats.org/drawingml/2006/main">
+            <a:off x="14103002" y="23733555"/>
             <a:ext cx="13546305" cy="393488"/>
           </a:xfrm>
           <a:prstGeom xmlns:a="http://schemas.openxmlformats.org/drawingml/2006/main" prst="rect">
@@ -3561,14 +3561,14 @@
           <a:lstStyle xmlns:a="http://schemas.openxmlformats.org/drawingml/2006/main"/>
           <a:p xmlns:a="http://schemas.openxmlformats.org/drawingml/2006/main">
             <a:pPr>
-              <a:defRPr sz="1923" i="1">
+              <a:defRPr sz="1923">
                 <a:solidFill>
                   <a:srgbClr val="2C8C99"/>
                 </a:solidFill>
               </a:defRPr>
             </a:pPr>
             <a:r>
-              <a:rPr sz="1923" i="1">
+              <a:rPr sz="1923">
                 <a:solidFill>
                   <a:srgbClr val="2C8C99"/>
                 </a:solidFill>
@@ -3583,7 +3583,7 @@
           <p:cNvPr id="56" name="validation-heading-title">
             <a:extLst xmlns:a="http://schemas.openxmlformats.org/drawingml/2006/main">
               <a:ext uri="{FF2B5EF4-FFF2-40B4-BE49-F238E27FC236}">
-                <a16:creationId xmlns:a16="http://schemas.microsoft.com/office/drawing/2014/main" id="{A9808795-6458-4FF4-AEAF-659EA653FB9A}"/>
+                <a16:creationId xmlns:a16="http://schemas.microsoft.com/office/drawing/2014/main" id="{4AF246B9-C75D-43E7-8B53-9C1BB719AE83}"/>
               </a:ext>
             </a:extLst>
           </p:cNvPr>
@@ -3623,7 +3623,7 @@
                   <a:srgbClr val="0F5F73"/>
                 </a:solidFill>
               </a:rPr>
-              <a:t>Independent and external validation</a:t>
+              <a:t>Robustness and validation</a:t>
             </a:r>
           </a:p>
         </p:txBody>
@@ -3633,7 +3633,7 @@
           <p:cNvPr id="57" name="validation-heading-rule">
             <a:extLst xmlns:a="http://schemas.openxmlformats.org/drawingml/2006/main">
               <a:ext uri="{FF2B5EF4-FFF2-40B4-BE49-F238E27FC236}">
-                <a16:creationId xmlns:a16="http://schemas.microsoft.com/office/drawing/2014/main" id="{3E87ED33-557E-491A-8030-22868B7DE573}"/>
+                <a16:creationId xmlns:a16="http://schemas.microsoft.com/office/drawing/2014/main" id="{337FAD41-3E2C-4DA1-90B9-2BD342E90EEF}"/>
               </a:ext>
             </a:extLst>
           </p:cNvPr>
@@ -3666,7 +3666,7 @@
           <p:cNvPr id="58" name="validation-panel">
             <a:extLst xmlns:a="http://schemas.openxmlformats.org/drawingml/2006/main">
               <a:ext uri="{FF2B5EF4-FFF2-40B4-BE49-F238E27FC236}">
-                <a16:creationId xmlns:a16="http://schemas.microsoft.com/office/drawing/2014/main" id="{75D6BF79-823B-400C-A220-DCE5634AABDC}"/>
+                <a16:creationId xmlns:a16="http://schemas.microsoft.com/office/drawing/2014/main" id="{C4D9CDFF-0717-4401-8A6E-2D4EF6AE5291}"/>
               </a:ext>
             </a:extLst>
           </p:cNvPr>
@@ -3701,7 +3701,7 @@
           <p:cNvPr id="59" name="validation">
             <a:extLst xmlns:a="http://schemas.openxmlformats.org/drawingml/2006/main">
               <a:ext uri="{FF2B5EF4-FFF2-40B4-BE49-F238E27FC236}">
-                <a16:creationId xmlns:a16="http://schemas.microsoft.com/office/drawing/2014/main" id="{1FA322F6-2B5A-4E76-9096-A4E44419DCA6}"/>
+                <a16:creationId xmlns:a16="http://schemas.microsoft.com/office/drawing/2014/main" id="{C9AE7C51-18B5-444E-9A07-912E05C6EF7B}"/>
               </a:ext>
             </a:extLst>
           </p:cNvPr>
@@ -3775,7 +3775,7 @@
                   <a:srgbClr val="102A43"/>
                 </a:solidFill>
               </a:rPr>
-              <a:t>• Negative or inconsistent findings</a:t>
+              <a:t>• Negative findings</a:t>
             </a:r>
           </a:p>
           <a:p xmlns:a="http://schemas.openxmlformats.org/drawingml/2006/main">
@@ -3802,7 +3802,7 @@
           <p:cNvPr id="60" name="validation-evidence">
             <a:extLst xmlns:a="http://schemas.openxmlformats.org/drawingml/2006/main">
               <a:ext uri="{FF2B5EF4-FFF2-40B4-BE49-F238E27FC236}">
-                <a16:creationId xmlns:a16="http://schemas.microsoft.com/office/drawing/2014/main" id="{6D219022-86A0-4176-8998-BAA878F41781}"/>
+                <a16:creationId xmlns:a16="http://schemas.microsoft.com/office/drawing/2014/main" id="{0C34941D-CF6A-4B40-8A16-32C0DE53B273}"/>
               </a:ext>
             </a:extLst>
           </p:cNvPr>
@@ -3830,14 +3830,14 @@
           <a:lstStyle xmlns:a="http://schemas.openxmlformats.org/drawingml/2006/main"/>
           <a:p xmlns:a="http://schemas.openxmlformats.org/drawingml/2006/main">
             <a:pPr>
-              <a:defRPr sz="1923" i="1">
+              <a:defRPr sz="1923">
                 <a:solidFill>
                   <a:srgbClr val="2C8C99"/>
                 </a:solidFill>
               </a:defRPr>
             </a:pPr>
             <a:r>
-              <a:rPr sz="1923" i="1">
+              <a:rPr sz="1923">
                 <a:solidFill>
                   <a:srgbClr val="2C8C99"/>
                 </a:solidFill>
@@ -3852,7 +3852,7 @@
           <p:cNvPr id="61" name="performance-strip">
             <a:extLst xmlns:a="http://schemas.openxmlformats.org/drawingml/2006/main">
               <a:ext uri="{FF2B5EF4-FFF2-40B4-BE49-F238E27FC236}">
-                <a16:creationId xmlns:a16="http://schemas.microsoft.com/office/drawing/2014/main" id="{9DEEB926-9010-4710-8577-A7EC785955DE}"/>
+                <a16:creationId xmlns:a16="http://schemas.microsoft.com/office/drawing/2014/main" id="{A470A55C-0780-4CE9-B361-E0C6A9EBA938}"/>
               </a:ext>
             </a:extLst>
           </p:cNvPr>
@@ -3885,7 +3885,7 @@
           <p:cNvPr id="62" name="performance-strip-text">
             <a:extLst xmlns:a="http://schemas.openxmlformats.org/drawingml/2006/main">
               <a:ext uri="{FF2B5EF4-FFF2-40B4-BE49-F238E27FC236}">
-                <a16:creationId xmlns:a16="http://schemas.microsoft.com/office/drawing/2014/main" id="{5E7BA41A-CFF3-4F50-8FBB-B781DFE9B275}"/>
+                <a16:creationId xmlns:a16="http://schemas.microsoft.com/office/drawing/2014/main" id="{26A91053-3898-40EB-88D9-3BFF7779D6A0}"/>
               </a:ext>
             </a:extLst>
           </p:cNvPr>
@@ -3925,7 +3925,7 @@
                   <a:srgbClr val="FFFFFF"/>
                 </a:solidFill>
               </a:rPr>
-              <a:t>Primary performance statistic or calibrated model comparison</a:t>
+              <a:t>Primary estimate · uncertainty · validation</a:t>
             </a:r>
           </a:p>
         </p:txBody>
@@ -3935,7 +3935,7 @@
           <p:cNvPr id="63" name="biology-heading-title">
             <a:extLst xmlns:a="http://schemas.openxmlformats.org/drawingml/2006/main">
               <a:ext uri="{FF2B5EF4-FFF2-40B4-BE49-F238E27FC236}">
-                <a16:creationId xmlns:a16="http://schemas.microsoft.com/office/drawing/2014/main" id="{3F050D49-7224-437F-8271-C9BD79CEAA5F}"/>
+                <a16:creationId xmlns:a16="http://schemas.microsoft.com/office/drawing/2014/main" id="{2CBABB0C-82B1-434C-B307-3BDE142CA0CD}"/>
               </a:ext>
             </a:extLst>
           </p:cNvPr>
@@ -3985,7 +3985,7 @@
           <p:cNvPr id="64" name="biology-heading-rule">
             <a:extLst xmlns:a="http://schemas.openxmlformats.org/drawingml/2006/main">
               <a:ext uri="{FF2B5EF4-FFF2-40B4-BE49-F238E27FC236}">
-                <a16:creationId xmlns:a16="http://schemas.microsoft.com/office/drawing/2014/main" id="{7CEC753D-3D8E-4614-B978-5D3DDB132336}"/>
+                <a16:creationId xmlns:a16="http://schemas.microsoft.com/office/drawing/2014/main" id="{FC53A03E-28C4-4D78-AE6A-C5C1A52BD4FC}"/>
               </a:ext>
             </a:extLst>
           </p:cNvPr>
@@ -4018,7 +4018,7 @@
           <p:cNvPr id="65" name="biology-1-value">
             <a:extLst xmlns:a="http://schemas.openxmlformats.org/drawingml/2006/main">
               <a:ext uri="{FF2B5EF4-FFF2-40B4-BE49-F238E27FC236}">
-                <a16:creationId xmlns:a16="http://schemas.microsoft.com/office/drawing/2014/main" id="{400F8203-B532-4B6C-B972-0C1BA7835902}"/>
+                <a16:creationId xmlns:a16="http://schemas.microsoft.com/office/drawing/2014/main" id="{767479BA-76D4-4E54-918A-65343A65F2B5}"/>
               </a:ext>
             </a:extLst>
           </p:cNvPr>
@@ -4068,18 +4068,18 @@
           <p:cNvPr id="66" name="biology-1-label">
             <a:extLst xmlns:a="http://schemas.openxmlformats.org/drawingml/2006/main">
               <a:ext uri="{FF2B5EF4-FFF2-40B4-BE49-F238E27FC236}">
-                <a16:creationId xmlns:a16="http://schemas.microsoft.com/office/drawing/2014/main" id="{C39A54F2-67CA-4917-AE92-EF4DA536E0BB}"/>
-              </a:ext>
-            </a:extLst>
-          </p:cNvPr>
-          <p:cNvSpPr>
-            <a:spLocks xmlns:a="http://schemas.openxmlformats.org/drawingml/2006/main" noGrp="1"/>
-          </p:cNvSpPr>
-          <p:nvPr/>
-        </p:nvSpPr>
-        <p:spPr>
-          <a:xfrm xmlns:a="http://schemas.openxmlformats.org/drawingml/2006/main">
-            <a:off x="28469704" y="7994025"/>
+                <a16:creationId xmlns:a16="http://schemas.microsoft.com/office/drawing/2014/main" id="{D433A23F-27B0-4207-B616-63BB9976177F}"/>
+              </a:ext>
+            </a:extLst>
+          </p:cNvPr>
+          <p:cNvSpPr>
+            <a:spLocks xmlns:a="http://schemas.openxmlformats.org/drawingml/2006/main" noGrp="1"/>
+          </p:cNvSpPr>
+          <p:nvPr/>
+        </p:nvSpPr>
+        <p:spPr>
+          <a:xfrm xmlns:a="http://schemas.openxmlformats.org/drawingml/2006/main">
+            <a:off x="28469704" y="7952605"/>
             <a:ext cx="4101981" cy="911236"/>
           </a:xfrm>
           <a:prstGeom xmlns:a="http://schemas.openxmlformats.org/drawingml/2006/main" prst="rect">
@@ -4108,7 +4108,7 @@
                   <a:srgbClr val="102A43"/>
                 </a:solidFill>
               </a:rPr>
-              <a:t>program or pathway</a:t>
+              <a:t>primary estimate</a:t>
             </a:r>
           </a:p>
         </p:txBody>
@@ -4118,7 +4118,7 @@
           <p:cNvPr id="67" name="biology-2-value">
             <a:extLst xmlns:a="http://schemas.openxmlformats.org/drawingml/2006/main">
               <a:ext uri="{FF2B5EF4-FFF2-40B4-BE49-F238E27FC236}">
-                <a16:creationId xmlns:a16="http://schemas.microsoft.com/office/drawing/2014/main" id="{13F7A0F1-A43F-400A-B000-74C4D8A49F0E}"/>
+                <a16:creationId xmlns:a16="http://schemas.microsoft.com/office/drawing/2014/main" id="{4D13A884-41F1-40AB-AABD-673802549B57}"/>
               </a:ext>
             </a:extLst>
           </p:cNvPr>
@@ -4158,7 +4158,7 @@
                   <a:srgbClr val="2C8C99"/>
                 </a:solidFill>
               </a:rPr>
-              <a:t>Effect</a:t>
+              <a:t>95% CI</a:t>
             </a:r>
           </a:p>
         </p:txBody>
@@ -4168,18 +4168,18 @@
           <p:cNvPr id="68" name="biology-2-label">
             <a:extLst xmlns:a="http://schemas.openxmlformats.org/drawingml/2006/main">
               <a:ext uri="{FF2B5EF4-FFF2-40B4-BE49-F238E27FC236}">
-                <a16:creationId xmlns:a16="http://schemas.microsoft.com/office/drawing/2014/main" id="{2FECD301-E8F5-41C9-9D0D-7973D5E37E7E}"/>
-              </a:ext>
-            </a:extLst>
-          </p:cNvPr>
-          <p:cNvSpPr>
-            <a:spLocks xmlns:a="http://schemas.openxmlformats.org/drawingml/2006/main" noGrp="1"/>
-          </p:cNvSpPr>
-          <p:nvPr/>
-        </p:nvSpPr>
-        <p:spPr>
-          <a:xfrm xmlns:a="http://schemas.openxmlformats.org/drawingml/2006/main">
-            <a:off x="33108849" y="7994025"/>
+                <a16:creationId xmlns:a16="http://schemas.microsoft.com/office/drawing/2014/main" id="{DB77922E-86BC-4739-BAFA-9C85C99E6F1B}"/>
+              </a:ext>
+            </a:extLst>
+          </p:cNvPr>
+          <p:cNvSpPr>
+            <a:spLocks xmlns:a="http://schemas.openxmlformats.org/drawingml/2006/main" noGrp="1"/>
+          </p:cNvSpPr>
+          <p:nvPr/>
+        </p:nvSpPr>
+        <p:spPr>
+          <a:xfrm xmlns:a="http://schemas.openxmlformats.org/drawingml/2006/main">
+            <a:off x="33108849" y="7952605"/>
             <a:ext cx="4101981" cy="911236"/>
           </a:xfrm>
           <a:prstGeom xmlns:a="http://schemas.openxmlformats.org/drawingml/2006/main" prst="rect">
@@ -4208,7 +4208,7 @@
                   <a:srgbClr val="102A43"/>
                 </a:solidFill>
               </a:rPr>
-              <a:t>program or pathway</a:t>
+              <a:t>uncertainty</a:t>
             </a:r>
           </a:p>
         </p:txBody>
@@ -4218,7 +4218,7 @@
           <p:cNvPr id="69" name="biology-3-value">
             <a:extLst xmlns:a="http://schemas.openxmlformats.org/drawingml/2006/main">
               <a:ext uri="{FF2B5EF4-FFF2-40B4-BE49-F238E27FC236}">
-                <a16:creationId xmlns:a16="http://schemas.microsoft.com/office/drawing/2014/main" id="{91BB219D-19AC-4F5D-9543-77EEB655DA84}"/>
+                <a16:creationId xmlns:a16="http://schemas.microsoft.com/office/drawing/2014/main" id="{6BCBB224-0D84-4E1F-9FFD-674D51B6CC8D}"/>
               </a:ext>
             </a:extLst>
           </p:cNvPr>
@@ -4258,7 +4258,7 @@
                   <a:srgbClr val="E8B44C"/>
                 </a:solidFill>
               </a:rPr>
-              <a:t>Effect</a:t>
+              <a:t>P</a:t>
             </a:r>
           </a:p>
         </p:txBody>
@@ -4268,18 +4268,18 @@
           <p:cNvPr id="70" name="biology-3-label">
             <a:extLst xmlns:a="http://schemas.openxmlformats.org/drawingml/2006/main">
               <a:ext uri="{FF2B5EF4-FFF2-40B4-BE49-F238E27FC236}">
-                <a16:creationId xmlns:a16="http://schemas.microsoft.com/office/drawing/2014/main" id="{5342B2A3-6708-4596-9BCC-16BA76F5C783}"/>
-              </a:ext>
-            </a:extLst>
-          </p:cNvPr>
-          <p:cNvSpPr>
-            <a:spLocks xmlns:a="http://schemas.openxmlformats.org/drawingml/2006/main" noGrp="1"/>
-          </p:cNvSpPr>
-          <p:nvPr/>
-        </p:nvSpPr>
-        <p:spPr>
-          <a:xfrm xmlns:a="http://schemas.openxmlformats.org/drawingml/2006/main">
-            <a:off x="37747995" y="7994025"/>
+                <a16:creationId xmlns:a16="http://schemas.microsoft.com/office/drawing/2014/main" id="{B62BF0C9-F3DC-4725-A7C2-A9E678044C0E}"/>
+              </a:ext>
+            </a:extLst>
+          </p:cNvPr>
+          <p:cNvSpPr>
+            <a:spLocks xmlns:a="http://schemas.openxmlformats.org/drawingml/2006/main" noGrp="1"/>
+          </p:cNvSpPr>
+          <p:nvPr/>
+        </p:nvSpPr>
+        <p:spPr>
+          <a:xfrm xmlns:a="http://schemas.openxmlformats.org/drawingml/2006/main">
+            <a:off x="37747995" y="7952605"/>
             <a:ext cx="4101981" cy="911236"/>
           </a:xfrm>
           <a:prstGeom xmlns:a="http://schemas.openxmlformats.org/drawingml/2006/main" prst="rect">
@@ -4308,7 +4308,7 @@
                   <a:srgbClr val="102A43"/>
                 </a:solidFill>
               </a:rPr>
-              <a:t>program or pathway</a:t>
+              <a:t>robustness</a:t>
             </a:r>
           </a:p>
         </p:txBody>
@@ -4318,7 +4318,7 @@
           <p:cNvPr id="71" name="biology-evidence">
             <a:extLst xmlns:a="http://schemas.openxmlformats.org/drawingml/2006/main">
               <a:ext uri="{FF2B5EF4-FFF2-40B4-BE49-F238E27FC236}">
-                <a16:creationId xmlns:a16="http://schemas.microsoft.com/office/drawing/2014/main" id="{27DEE4CA-E140-448F-A991-3D49C294B6FE}"/>
+                <a16:creationId xmlns:a16="http://schemas.microsoft.com/office/drawing/2014/main" id="{B52AD81D-18CA-41A5-B086-B8A6CF511F39}"/>
               </a:ext>
             </a:extLst>
           </p:cNvPr>
@@ -4346,19 +4346,19 @@
           <a:lstStyle xmlns:a="http://schemas.openxmlformats.org/drawingml/2006/main"/>
           <a:p xmlns:a="http://schemas.openxmlformats.org/drawingml/2006/main">
             <a:pPr>
-              <a:defRPr sz="1923" i="1">
+              <a:defRPr sz="1923">
                 <a:solidFill>
                   <a:srgbClr val="2C8C99"/>
                 </a:solidFill>
               </a:defRPr>
             </a:pPr>
             <a:r>
-              <a:rPr sz="1923" i="1">
+              <a:rPr sz="1923">
                 <a:solidFill>
                   <a:srgbClr val="2C8C99"/>
                 </a:solidFill>
               </a:rPr>
-              <a:t>Evidence: biological analysis</a:t>
+              <a:t>Evidence: supporting analysis</a:t>
             </a:r>
           </a:p>
         </p:txBody>
@@ -4368,7 +4368,7 @@
           <p:cNvPr id="72" name="figure-three-frame">
             <a:extLst xmlns:a="http://schemas.openxmlformats.org/drawingml/2006/main">
               <a:ext uri="{FF2B5EF4-FFF2-40B4-BE49-F238E27FC236}">
-                <a16:creationId xmlns:a16="http://schemas.microsoft.com/office/drawing/2014/main" id="{4CDB5DCA-EE57-4FD5-B5B2-1D461E2E8CCF}"/>
+                <a16:creationId xmlns:a16="http://schemas.microsoft.com/office/drawing/2014/main" id="{4CF74A15-869F-4F99-BAE7-7FB0CC20DACA}"/>
               </a:ext>
             </a:extLst>
           </p:cNvPr>
@@ -4403,7 +4403,7 @@
           <p:cNvPr id="73" name="figure-three-placeholder">
             <a:extLst xmlns:a="http://schemas.openxmlformats.org/drawingml/2006/main">
               <a:ext uri="{FF2B5EF4-FFF2-40B4-BE49-F238E27FC236}">
-                <a16:creationId xmlns:a16="http://schemas.microsoft.com/office/drawing/2014/main" id="{6A79DE85-412F-4E61-8286-BB63C38745BC}"/>
+                <a16:creationId xmlns:a16="http://schemas.microsoft.com/office/drawing/2014/main" id="{37920CAA-651F-4E01-98E9-C5193A042493}"/>
               </a:ext>
             </a:extLst>
           </p:cNvPr>
@@ -4438,7 +4438,7 @@
           <p:cNvPr id="74" name="figure-three-placeholder-label">
             <a:extLst xmlns:a="http://schemas.openxmlformats.org/drawingml/2006/main">
               <a:ext uri="{FF2B5EF4-FFF2-40B4-BE49-F238E27FC236}">
-                <a16:creationId xmlns:a16="http://schemas.microsoft.com/office/drawing/2014/main" id="{8D39F215-EF07-4413-A611-6734251AB9B9}"/>
+                <a16:creationId xmlns:a16="http://schemas.microsoft.com/office/drawing/2014/main" id="{65D6F4D8-473E-40C0-85F1-CFF425CC6BB0}"/>
               </a:ext>
             </a:extLst>
           </p:cNvPr>
@@ -4478,7 +4478,7 @@
                   <a:srgbClr val="2C8C99"/>
                 </a:solidFill>
               </a:rPr>
-              <a:t>SCIENTIFIC FIGURE</a:t>
+              <a:t>scientific figure</a:t>
             </a:r>
           </a:p>
         </p:txBody>
@@ -4488,7 +4488,7 @@
           <p:cNvPr id="75" name="figure-three-caption">
             <a:extLst xmlns:a="http://schemas.openxmlformats.org/drawingml/2006/main">
               <a:ext uri="{FF2B5EF4-FFF2-40B4-BE49-F238E27FC236}">
-                <a16:creationId xmlns:a16="http://schemas.microsoft.com/office/drawing/2014/main" id="{AF7F3A15-93D9-4978-91E4-D0704FA7F884}"/>
+                <a16:creationId xmlns:a16="http://schemas.microsoft.com/office/drawing/2014/main" id="{ABB43541-A75F-47B5-B0FB-8D353B1F8B04}"/>
               </a:ext>
             </a:extLst>
           </p:cNvPr>
@@ -4500,7 +4500,7 @@
         <p:spPr>
           <a:xfrm xmlns:a="http://schemas.openxmlformats.org/drawingml/2006/main">
             <a:off x="28704103" y="16702541"/>
-            <a:ext cx="13585371" cy="434908"/>
+            <a:ext cx="13585371" cy="341713"/>
           </a:xfrm>
           <a:prstGeom xmlns:a="http://schemas.openxmlformats.org/drawingml/2006/main" prst="rect">
             <a:avLst/>
@@ -4528,7 +4528,7 @@
                   <a:srgbClr val="102A43"/>
                 </a:solidFill>
               </a:rPr>
-              <a:t>Figure caption</a:t>
+              <a:t>Scientific Figure caption</a:t>
             </a:r>
           </a:p>
         </p:txBody>
@@ -4538,18 +4538,18 @@
           <p:cNvPr id="76" name="figure-three-source">
             <a:extLst xmlns:a="http://schemas.openxmlformats.org/drawingml/2006/main">
               <a:ext uri="{FF2B5EF4-FFF2-40B4-BE49-F238E27FC236}">
-                <a16:creationId xmlns:a16="http://schemas.microsoft.com/office/drawing/2014/main" id="{27574BF0-C3A7-42AF-B7C4-56770436E2D3}"/>
-              </a:ext>
-            </a:extLst>
-          </p:cNvPr>
-          <p:cNvSpPr>
-            <a:spLocks xmlns:a="http://schemas.openxmlformats.org/drawingml/2006/main" noGrp="1"/>
-          </p:cNvSpPr>
-          <p:nvPr/>
-        </p:nvSpPr>
-        <p:spPr>
-          <a:xfrm xmlns:a="http://schemas.openxmlformats.org/drawingml/2006/main">
-            <a:off x="28704103" y="17044255"/>
+                <a16:creationId xmlns:a16="http://schemas.microsoft.com/office/drawing/2014/main" id="{B49AB330-2906-4BCE-81C8-21FF9CED1C68}"/>
+              </a:ext>
+            </a:extLst>
+          </p:cNvPr>
+          <p:cNvSpPr>
+            <a:spLocks xmlns:a="http://schemas.openxmlformats.org/drawingml/2006/main" noGrp="1"/>
+          </p:cNvSpPr>
+          <p:nvPr/>
+        </p:nvSpPr>
+        <p:spPr>
+          <a:xfrm xmlns:a="http://schemas.openxmlformats.org/drawingml/2006/main">
+            <a:off x="28704103" y="17054610"/>
             <a:ext cx="13585371" cy="393488"/>
           </a:xfrm>
           <a:prstGeom xmlns:a="http://schemas.openxmlformats.org/drawingml/2006/main" prst="rect">
@@ -4566,14 +4566,14 @@
           <a:lstStyle xmlns:a="http://schemas.openxmlformats.org/drawingml/2006/main"/>
           <a:p xmlns:a="http://schemas.openxmlformats.org/drawingml/2006/main">
             <a:pPr>
-              <a:defRPr sz="1923" i="1">
+              <a:defRPr sz="1923">
                 <a:solidFill>
                   <a:srgbClr val="2C8C99"/>
                 </a:solidFill>
               </a:defRPr>
             </a:pPr>
             <a:r>
-              <a:rPr sz="1923" i="1">
+              <a:rPr sz="1923">
                 <a:solidFill>
                   <a:srgbClr val="2C8C99"/>
                 </a:solidFill>
@@ -4588,7 +4588,7 @@
           <p:cNvPr id="77" name="validation-visual-heading-title">
             <a:extLst xmlns:a="http://schemas.openxmlformats.org/drawingml/2006/main">
               <a:ext uri="{FF2B5EF4-FFF2-40B4-BE49-F238E27FC236}">
-                <a16:creationId xmlns:a16="http://schemas.microsoft.com/office/drawing/2014/main" id="{2FB44B95-0149-4187-8854-5C36D831210B}"/>
+                <a16:creationId xmlns:a16="http://schemas.microsoft.com/office/drawing/2014/main" id="{12CF690D-D34A-4901-9A8C-FCED18B65D34}"/>
               </a:ext>
             </a:extLst>
           </p:cNvPr>
@@ -4638,7 +4638,7 @@
           <p:cNvPr id="78" name="validation-visual-heading-rule">
             <a:extLst xmlns:a="http://schemas.openxmlformats.org/drawingml/2006/main">
               <a:ext uri="{FF2B5EF4-FFF2-40B4-BE49-F238E27FC236}">
-                <a16:creationId xmlns:a16="http://schemas.microsoft.com/office/drawing/2014/main" id="{54538299-84B5-4EDA-B0AD-52EFDADD3A4A}"/>
+                <a16:creationId xmlns:a16="http://schemas.microsoft.com/office/drawing/2014/main" id="{DF59438B-12E0-4E05-AFE6-809349F5A059}"/>
               </a:ext>
             </a:extLst>
           </p:cNvPr>
@@ -4671,7 +4671,7 @@
           <p:cNvPr id="79" name="figure-four-frame">
             <a:extLst xmlns:a="http://schemas.openxmlformats.org/drawingml/2006/main">
               <a:ext uri="{FF2B5EF4-FFF2-40B4-BE49-F238E27FC236}">
-                <a16:creationId xmlns:a16="http://schemas.microsoft.com/office/drawing/2014/main" id="{9C2C2F45-8547-4841-B20C-2ADA5BA236E3}"/>
+                <a16:creationId xmlns:a16="http://schemas.microsoft.com/office/drawing/2014/main" id="{1D242206-0F04-4838-9D3A-7A40ACE01646}"/>
               </a:ext>
             </a:extLst>
           </p:cNvPr>
@@ -4706,7 +4706,7 @@
           <p:cNvPr id="80" name="figure-four-placeholder">
             <a:extLst xmlns:a="http://schemas.openxmlformats.org/drawingml/2006/main">
               <a:ext uri="{FF2B5EF4-FFF2-40B4-BE49-F238E27FC236}">
-                <a16:creationId xmlns:a16="http://schemas.microsoft.com/office/drawing/2014/main" id="{F4EB6BC2-FE49-4202-A25A-D54E60FAD742}"/>
+                <a16:creationId xmlns:a16="http://schemas.microsoft.com/office/drawing/2014/main" id="{6C87E0FB-3BC4-4A22-9A91-22C28369B966}"/>
               </a:ext>
             </a:extLst>
           </p:cNvPr>
@@ -4741,7 +4741,7 @@
           <p:cNvPr id="81" name="figure-four-placeholder-label">
             <a:extLst xmlns:a="http://schemas.openxmlformats.org/drawingml/2006/main">
               <a:ext uri="{FF2B5EF4-FFF2-40B4-BE49-F238E27FC236}">
-                <a16:creationId xmlns:a16="http://schemas.microsoft.com/office/drawing/2014/main" id="{58C9E67F-5F5D-4A53-A985-10CCE6B73EC0}"/>
+                <a16:creationId xmlns:a16="http://schemas.microsoft.com/office/drawing/2014/main" id="{A99B4402-B10D-4AE4-80F3-7EFF57934CFB}"/>
               </a:ext>
             </a:extLst>
           </p:cNvPr>
@@ -4781,7 +4781,7 @@
                   <a:srgbClr val="2C8C99"/>
                 </a:solidFill>
               </a:rPr>
-              <a:t>SCIENTIFIC FIGURE</a:t>
+              <a:t>scientific figure</a:t>
             </a:r>
           </a:p>
         </p:txBody>
@@ -4791,7 +4791,7 @@
           <p:cNvPr id="82" name="figure-four-caption">
             <a:extLst xmlns:a="http://schemas.openxmlformats.org/drawingml/2006/main">
               <a:ext uri="{FF2B5EF4-FFF2-40B4-BE49-F238E27FC236}">
-                <a16:creationId xmlns:a16="http://schemas.microsoft.com/office/drawing/2014/main" id="{4AC33B00-E29A-4F7C-8D20-4C6BC7B0C9B8}"/>
+                <a16:creationId xmlns:a16="http://schemas.microsoft.com/office/drawing/2014/main" id="{0A172FEF-F199-4DCD-B8AE-8D3D8D3FEBB3}"/>
               </a:ext>
             </a:extLst>
           </p:cNvPr>
@@ -4803,7 +4803,7 @@
         <p:spPr>
           <a:xfrm xmlns:a="http://schemas.openxmlformats.org/drawingml/2006/main">
             <a:off x="28704103" y="25918451"/>
-            <a:ext cx="13585371" cy="434908"/>
+            <a:ext cx="13585371" cy="341713"/>
           </a:xfrm>
           <a:prstGeom xmlns:a="http://schemas.openxmlformats.org/drawingml/2006/main" prst="rect">
             <a:avLst/>
@@ -4831,7 +4831,7 @@
                   <a:srgbClr val="102A43"/>
                 </a:solidFill>
               </a:rPr>
-              <a:t>Figure caption</a:t>
+              <a:t>Scientific Figure caption</a:t>
             </a:r>
           </a:p>
         </p:txBody>
@@ -4841,18 +4841,18 @@
           <p:cNvPr id="83" name="figure-four-source">
             <a:extLst xmlns:a="http://schemas.openxmlformats.org/drawingml/2006/main">
               <a:ext uri="{FF2B5EF4-FFF2-40B4-BE49-F238E27FC236}">
-                <a16:creationId xmlns:a16="http://schemas.microsoft.com/office/drawing/2014/main" id="{9959498F-DE75-4F52-BD8A-BE692C2B3EDB}"/>
-              </a:ext>
-            </a:extLst>
-          </p:cNvPr>
-          <p:cNvSpPr>
-            <a:spLocks xmlns:a="http://schemas.openxmlformats.org/drawingml/2006/main" noGrp="1"/>
-          </p:cNvSpPr>
-          <p:nvPr/>
-        </p:nvSpPr>
-        <p:spPr>
-          <a:xfrm xmlns:a="http://schemas.openxmlformats.org/drawingml/2006/main">
-            <a:off x="28704103" y="26260164"/>
+                <a16:creationId xmlns:a16="http://schemas.microsoft.com/office/drawing/2014/main" id="{211E7CDA-80BF-466A-922E-A2456BBD335D}"/>
+              </a:ext>
+            </a:extLst>
+          </p:cNvPr>
+          <p:cNvSpPr>
+            <a:spLocks xmlns:a="http://schemas.openxmlformats.org/drawingml/2006/main" noGrp="1"/>
+          </p:cNvSpPr>
+          <p:nvPr/>
+        </p:nvSpPr>
+        <p:spPr>
+          <a:xfrm xmlns:a="http://schemas.openxmlformats.org/drawingml/2006/main">
+            <a:off x="28704103" y="26270519"/>
             <a:ext cx="13585371" cy="393488"/>
           </a:xfrm>
           <a:prstGeom xmlns:a="http://schemas.openxmlformats.org/drawingml/2006/main" prst="rect">
@@ -4869,14 +4869,14 @@
           <a:lstStyle xmlns:a="http://schemas.openxmlformats.org/drawingml/2006/main"/>
           <a:p xmlns:a="http://schemas.openxmlformats.org/drawingml/2006/main">
             <a:pPr>
-              <a:defRPr sz="1923" i="1">
+              <a:defRPr sz="1923">
                 <a:solidFill>
                   <a:srgbClr val="2C8C99"/>
                 </a:solidFill>
               </a:defRPr>
             </a:pPr>
             <a:r>
-              <a:rPr sz="1923" i="1">
+              <a:rPr sz="1923">
                 <a:solidFill>
                   <a:srgbClr val="2C8C99"/>
                 </a:solidFill>
@@ -4891,7 +4891,7 @@
           <p:cNvPr id="84" name="conclusion-heading-title">
             <a:extLst xmlns:a="http://schemas.openxmlformats.org/drawingml/2006/main">
               <a:ext uri="{FF2B5EF4-FFF2-40B4-BE49-F238E27FC236}">
-                <a16:creationId xmlns:a16="http://schemas.microsoft.com/office/drawing/2014/main" id="{00924B8D-05EA-4866-B32F-73327A7DBD19}"/>
+                <a16:creationId xmlns:a16="http://schemas.microsoft.com/office/drawing/2014/main" id="{7B3D05BB-D7B2-4346-9CF8-9785143475CE}"/>
               </a:ext>
             </a:extLst>
           </p:cNvPr>
@@ -4941,7 +4941,7 @@
           <p:cNvPr id="85" name="conclusion-heading-rule">
             <a:extLst xmlns:a="http://schemas.openxmlformats.org/drawingml/2006/main">
               <a:ext uri="{FF2B5EF4-FFF2-40B4-BE49-F238E27FC236}">
-                <a16:creationId xmlns:a16="http://schemas.microsoft.com/office/drawing/2014/main" id="{6B9ECC58-1A8C-493C-A488-21C0C4307C9D}"/>
+                <a16:creationId xmlns:a16="http://schemas.microsoft.com/office/drawing/2014/main" id="{AF9C1C59-A97D-4BE1-A858-B3F2FA7CD2E3}"/>
               </a:ext>
             </a:extLst>
           </p:cNvPr>
@@ -4974,7 +4974,7 @@
           <p:cNvPr id="86" name="conclusion-panel">
             <a:extLst xmlns:a="http://schemas.openxmlformats.org/drawingml/2006/main">
               <a:ext uri="{FF2B5EF4-FFF2-40B4-BE49-F238E27FC236}">
-                <a16:creationId xmlns:a16="http://schemas.microsoft.com/office/drawing/2014/main" id="{740FB02A-F61F-4B90-AA28-680C72A9E41B}"/>
+                <a16:creationId xmlns:a16="http://schemas.microsoft.com/office/drawing/2014/main" id="{80A87FB7-7B5A-4BC6-BC67-8973565F1E6E}"/>
               </a:ext>
             </a:extLst>
           </p:cNvPr>
@@ -5009,7 +5009,7 @@
           <p:cNvPr id="87" name="conclusion">
             <a:extLst xmlns:a="http://schemas.openxmlformats.org/drawingml/2006/main">
               <a:ext uri="{FF2B5EF4-FFF2-40B4-BE49-F238E27FC236}">
-                <a16:creationId xmlns:a16="http://schemas.microsoft.com/office/drawing/2014/main" id="{5074A9B5-5FB9-4428-BC16-C641901516A9}"/>
+                <a16:creationId xmlns:a16="http://schemas.microsoft.com/office/drawing/2014/main" id="{4AC729CD-1C89-4497-963D-F33089622F95}"/>
               </a:ext>
             </a:extLst>
           </p:cNvPr>
@@ -5059,7 +5059,7 @@
           <p:cNvPr id="88" name="conclusion-evidence">
             <a:extLst xmlns:a="http://schemas.openxmlformats.org/drawingml/2006/main">
               <a:ext uri="{FF2B5EF4-FFF2-40B4-BE49-F238E27FC236}">
-                <a16:creationId xmlns:a16="http://schemas.microsoft.com/office/drawing/2014/main" id="{80BB9896-CCCE-44FC-9482-821C9B106019}"/>
+                <a16:creationId xmlns:a16="http://schemas.microsoft.com/office/drawing/2014/main" id="{5FE8EB09-9DA2-4CFA-B79E-7B37D33CBEEC}"/>
               </a:ext>
             </a:extLst>
           </p:cNvPr>
@@ -5087,14 +5087,14 @@
           <a:lstStyle xmlns:a="http://schemas.openxmlformats.org/drawingml/2006/main"/>
           <a:p xmlns:a="http://schemas.openxmlformats.org/drawingml/2006/main">
             <a:pPr>
-              <a:defRPr sz="1923" i="1">
+              <a:defRPr sz="1923">
                 <a:solidFill>
                   <a:srgbClr val="2C8C99"/>
                 </a:solidFill>
               </a:defRPr>
             </a:pPr>
             <a:r>
-              <a:rPr sz="1923" i="1">
+              <a:rPr sz="1923">
                 <a:solidFill>
                   <a:srgbClr val="2C8C99"/>
                 </a:solidFill>
@@ -5109,7 +5109,7 @@
           <p:cNvPr id="89" name="footer-band">
             <a:extLst xmlns:a="http://schemas.openxmlformats.org/drawingml/2006/main">
               <a:ext uri="{FF2B5EF4-FFF2-40B4-BE49-F238E27FC236}">
-                <a16:creationId xmlns:a16="http://schemas.microsoft.com/office/drawing/2014/main" id="{C73C2881-8F4C-4427-8A56-FB48FCC769DE}"/>
+                <a16:creationId xmlns:a16="http://schemas.microsoft.com/office/drawing/2014/main" id="{F59322CF-354B-4236-87F1-4A63F9AA2457}"/>
               </a:ext>
             </a:extLst>
           </p:cNvPr>
@@ -5142,7 +5142,7 @@
           <p:cNvPr id="90" name="footer-source">
             <a:extLst xmlns:a="http://schemas.openxmlformats.org/drawingml/2006/main">
               <a:ext uri="{FF2B5EF4-FFF2-40B4-BE49-F238E27FC236}">
-                <a16:creationId xmlns:a16="http://schemas.microsoft.com/office/drawing/2014/main" id="{B5B369D5-2801-4F21-9824-AABDD422054B}"/>
+                <a16:creationId xmlns:a16="http://schemas.microsoft.com/office/drawing/2014/main" id="{1225F07B-B60D-464E-BA0F-2F451DFE323D}"/>
               </a:ext>
             </a:extLst>
           </p:cNvPr>
@@ -5154,7 +5154,7 @@
         <p:spPr>
           <a:xfrm xmlns:a="http://schemas.openxmlformats.org/drawingml/2006/main">
             <a:off x="1367327" y="32172843"/>
-            <a:ext cx="29299866" cy="434908"/>
+            <a:ext cx="19630911" cy="434908"/>
           </a:xfrm>
           <a:prstGeom xmlns:a="http://schemas.openxmlformats.org/drawingml/2006/main" prst="rect">
             <a:avLst/>
@@ -5192,19 +5192,19 @@
           <p:cNvPr id="91" name="footer-status">
             <a:extLst xmlns:a="http://schemas.openxmlformats.org/drawingml/2006/main">
               <a:ext uri="{FF2B5EF4-FFF2-40B4-BE49-F238E27FC236}">
-                <a16:creationId xmlns:a16="http://schemas.microsoft.com/office/drawing/2014/main" id="{C6E10EB2-4C63-4921-B0DB-76EEA3479C21}"/>
-              </a:ext>
-            </a:extLst>
-          </p:cNvPr>
-          <p:cNvSpPr>
-            <a:spLocks xmlns:a="http://schemas.openxmlformats.org/drawingml/2006/main" noGrp="1"/>
-          </p:cNvSpPr>
-          <p:nvPr/>
-        </p:nvSpPr>
-        <p:spPr>
-          <a:xfrm xmlns:a="http://schemas.openxmlformats.org/drawingml/2006/main">
-            <a:off x="30471861" y="32172843"/>
-            <a:ext cx="12012945" cy="434908"/>
+                <a16:creationId xmlns:a16="http://schemas.microsoft.com/office/drawing/2014/main" id="{E2C8C207-D263-4464-B000-A36AF0366EE5}"/>
+              </a:ext>
+            </a:extLst>
+          </p:cNvPr>
+          <p:cNvSpPr>
+            <a:spLocks xmlns:a="http://schemas.openxmlformats.org/drawingml/2006/main" noGrp="1"/>
+          </p:cNvSpPr>
+          <p:nvPr/>
+        </p:nvSpPr>
+        <p:spPr>
+          <a:xfrm xmlns:a="http://schemas.openxmlformats.org/drawingml/2006/main">
+            <a:off x="21291236" y="32172843"/>
+            <a:ext cx="8887626" cy="434908"/>
           </a:xfrm>
           <a:prstGeom xmlns:a="http://schemas.openxmlformats.org/drawingml/2006/main" prst="rect">
             <a:avLst/>
@@ -5220,19 +5220,73 @@
           <a:lstStyle xmlns:a="http://schemas.openxmlformats.org/drawingml/2006/main"/>
           <a:p xmlns:a="http://schemas.openxmlformats.org/drawingml/2006/main">
             <a:pPr algn="r">
-              <a:defRPr sz="1923" b="1">
+              <a:defRPr sz="1846" b="1">
                 <a:solidFill>
                   <a:srgbClr val="E8B44C"/>
                 </a:solidFill>
               </a:defRPr>
             </a:pPr>
             <a:r>
-              <a:rPr sz="1923" b="1">
+              <a:rPr sz="1846" b="1">
                 <a:solidFill>
                   <a:srgbClr val="E8B44C"/>
                 </a:solidFill>
               </a:rPr>
-              <a:t>Approval status · scientific colors locked</a:t>
+              <a:t>Approvals current · scientific colors locked</a:t>
+            </a:r>
+          </a:p>
+        </p:txBody>
+      </p:sp>
+      <p:sp>
+        <p:nvSpPr>
+          <p:cNvPr id="92" name="POSTEX_PROVENANCE_MARK">
+            <a:extLst xmlns:a="http://schemas.openxmlformats.org/drawingml/2006/main">
+              <a:ext uri="{FF2B5EF4-FFF2-40B4-BE49-F238E27FC236}">
+                <a16:creationId xmlns:a16="http://schemas.microsoft.com/office/drawing/2014/main" id="{8E642387-AD4D-44A2-9E65-00E4618A23BD}"/>
+              </a:ext>
+            </a:extLst>
+          </p:cNvPr>
+          <p:cNvSpPr>
+            <a:spLocks xmlns:a="http://schemas.openxmlformats.org/drawingml/2006/main" noGrp="1"/>
+          </p:cNvSpPr>
+          <p:nvPr/>
+        </p:nvSpPr>
+        <p:spPr>
+          <a:xfrm xmlns:a="http://schemas.openxmlformats.org/drawingml/2006/main">
+            <a:off x="31057858" y="32172843"/>
+            <a:ext cx="11426948" cy="434908"/>
+          </a:xfrm>
+          <a:prstGeom xmlns:a="http://schemas.openxmlformats.org/drawingml/2006/main" prst="rect">
+            <a:avLst/>
+          </a:prstGeom>
+          <a:noFill xmlns:a="http://schemas.openxmlformats.org/drawingml/2006/main"/>
+          <a:ln xmlns:a="http://schemas.openxmlformats.org/drawingml/2006/main" w="0">
+            <a:noFill/>
+            <a:prstDash val="solid"/>
+          </a:ln>
+        </p:spPr>
+        <p:txBody>
+          <a:bodyPr xmlns:a="http://schemas.openxmlformats.org/drawingml/2006/main"/>
+          <a:lstStyle xmlns:a="http://schemas.openxmlformats.org/drawingml/2006/main"/>
+          <a:p xmlns:a="http://schemas.openxmlformats.org/drawingml/2006/main">
+            <a:pPr algn="r">
+              <a:defRPr sz="1846" b="1">
+                <a:solidFill>
+                  <a:srgbClr val="FFFFFF">
+                    <a:alpha val="38000"/>
+                  </a:srgbClr>
+                </a:solidFill>
+              </a:defRPr>
+            </a:pPr>
+            <a:r>
+              <a:rPr sz="1846" b="1">
+                <a:solidFill>
+                  <a:srgbClr val="FFFFFF">
+                    <a:alpha val="38000"/>
+                  </a:srgbClr>
+                </a:solidFill>
+              </a:rPr>
+              <a:t>Made with PostEx™ · PX-00000000</a:t>
             </a:r>
           </a:p>
         </p:txBody>
@@ -5240,7 +5294,7 @@
     </p:spTree>
     <p:extLst>
       <p:ext uri="{BB962C8B-B14F-4D97-AF65-F5344CB8AC3E}">
-        <p14:creationId xmlns:p14="http://schemas.microsoft.com/office/powerpoint/2010/main" val="624803568"/>
+        <p14:creationId xmlns:p14="http://schemas.microsoft.com/office/powerpoint/2010/main" val="1661247704"/>
       </p:ext>
     </p:extLst>
   </p:cSld>

</xml_diff>